<commit_message>
Enhance PPTX with vibrant blue theme
- Accent bars: vivid blue (#2563EB)
- Subtitle text: bright sky blue (#93C5FD)
- Light backgrounds: blue-tinted white (#EFF6FF)
- Card accents: sky blue, indigo, teal
- Theme colors updated for consistency
- All screenshots preserved unchanged

Co-Authored-By: Claude Opus 4.6 <noreply@anthropic.com>
</commit_message>
<xml_diff>
--- a/MuleSoft-to-SpringBoot-Migrator-Technical-Presentation.pptx
+++ b/MuleSoft-to-SpringBoot-Migrator-Technical-Presentation.pptx
@@ -1416,7 +1416,7 @@
     <p:bg>
       <p:bgPr>
         <a:solidFill>
-          <a:srgbClr val="0F1F3D"/>
+          <a:srgbClr val="0B1A33"/>
         </a:solidFill>
         <a:effectLst/>
       </p:bgPr>
@@ -1450,7 +1450,7 @@
             <a:avLst/>
           </a:prstGeom>
           <a:solidFill>
-            <a:srgbClr val="0070AD"/>
+            <a:srgbClr val="2563EB"/>
           </a:solidFill>
           <a:ln/>
         </p:spPr>
@@ -1528,7 +1528,7 @@
             <a:r>
               <a:rPr lang="en-US" sz="3200" dirty="0" err="1">
                 <a:solidFill>
-                  <a:srgbClr val="CADCFC"/>
+                  <a:srgbClr val="93C5FD"/>
                 </a:solidFill>
                 <a:latin typeface="Calibri" pitchFamily="34" charset="0"/>
                 <a:ea typeface="Calibri" pitchFamily="34" charset="-122"/>
@@ -1539,13 +1539,13 @@
             <a:r>
               <a:rPr lang="en-US" sz="3200" dirty="0">
                 <a:solidFill>
-                  <a:srgbClr val="CADCFC"/>
-                </a:solidFill>
-                <a:latin typeface="Calibri" pitchFamily="34" charset="0"/>
-                <a:ea typeface="Calibri" pitchFamily="34" charset="-122"/>
-                <a:cs typeface="Calibri" pitchFamily="34" charset="-120"/>
-              </a:rPr>
-              <a:t> Migrator</a:t>
+                  <a:srgbClr val="93C5FD"/>
+                </a:solidFill>
+                <a:latin typeface="Calibri" pitchFamily="34" charset="0"/>
+                <a:ea typeface="Calibri" pitchFamily="34" charset="-122"/>
+                <a:cs typeface="Calibri" pitchFamily="34" charset="-120"/>
+              </a:rPr>
+              <a:t xml:space="preserve"> Migrator</a:t>
             </a:r>
             <a:endParaRPr lang="en-US" sz="3200" dirty="0"/>
           </a:p>
@@ -1578,7 +1578,7 @@
             <a:r>
               <a:rPr lang="en-US" sz="1400" dirty="0">
                 <a:solidFill>
-                  <a:srgbClr val="6B7280"/>
+                  <a:srgbClr val="64748B"/>
                 </a:solidFill>
                 <a:latin typeface="Calibri" pitchFamily="34" charset="0"/>
                 <a:ea typeface="Calibri" pitchFamily="34" charset="-122"/>
@@ -1617,7 +1617,7 @@
             <a:r>
               <a:rPr lang="en-US" sz="1000" dirty="0">
                 <a:solidFill>
-                  <a:srgbClr val="6B7280"/>
+                  <a:srgbClr val="64748B"/>
                 </a:solidFill>
                 <a:latin typeface="Calibri" pitchFamily="34" charset="0"/>
                 <a:ea typeface="Calibri" pitchFamily="34" charset="-122"/>
@@ -1656,7 +1656,7 @@
             <a:r>
               <a:rPr lang="en-US" sz="900" dirty="0">
                 <a:solidFill>
-                  <a:srgbClr val="6B7280"/>
+                  <a:srgbClr val="64748B"/>
                 </a:solidFill>
                 <a:latin typeface="Calibri" pitchFamily="34" charset="0"/>
                 <a:ea typeface="Calibri" pitchFamily="34" charset="-122"/>
@@ -1922,7 +1922,7 @@
     <p:bg>
       <p:bgPr>
         <a:solidFill>
-          <a:srgbClr val="0F1F3D"/>
+          <a:srgbClr val="0B1A33"/>
         </a:solidFill>
         <a:effectLst/>
       </p:bgPr>
@@ -1956,7 +1956,7 @@
             <a:avLst/>
           </a:prstGeom>
           <a:solidFill>
-            <a:srgbClr val="0070AD"/>
+            <a:srgbClr val="2563EB"/>
           </a:solidFill>
           <a:ln/>
         </p:spPr>
@@ -2034,7 +2034,7 @@
             <a:r>
               <a:rPr lang="en-US" sz="1300" dirty="0">
                 <a:solidFill>
-                  <a:srgbClr val="CADCFC"/>
+                  <a:srgbClr val="93C5FD"/>
                 </a:solidFill>
                 <a:latin typeface="Calibri" pitchFamily="34" charset="0"/>
                 <a:ea typeface="Calibri" pitchFamily="34" charset="-122"/>
@@ -2061,7 +2061,7 @@
             <a:avLst/>
           </a:prstGeom>
           <a:solidFill>
-            <a:srgbClr val="1E293B"/>
+            <a:srgbClr val="162032"/>
           </a:solidFill>
           <a:ln/>
           <a:effectLst>
@@ -2095,7 +2095,7 @@
             <a:avLst/>
           </a:prstGeom>
           <a:solidFill>
-            <a:srgbClr val="0070AD"/>
+            <a:srgbClr val="2563EB"/>
           </a:solidFill>
           <a:ln/>
         </p:spPr>
@@ -2122,7 +2122,7 @@
             <a:avLst/>
           </a:prstGeom>
           <a:solidFill>
-            <a:srgbClr val="0070AD"/>
+            <a:srgbClr val="2563EB"/>
           </a:solidFill>
           <a:ln/>
         </p:spPr>
@@ -2242,7 +2242,7 @@
             <a:r>
               <a:rPr lang="en-US" sz="850" dirty="0">
                 <a:solidFill>
-                  <a:srgbClr val="CADCFC"/>
+                  <a:srgbClr val="93C5FD"/>
                 </a:solidFill>
                 <a:latin typeface="Calibri" pitchFamily="34" charset="0"/>
                 <a:ea typeface="Calibri" pitchFamily="34" charset="-122"/>
@@ -2262,7 +2262,7 @@
             <a:r>
               <a:rPr lang="en-US" sz="850" dirty="0">
                 <a:solidFill>
-                  <a:srgbClr val="CADCFC"/>
+                  <a:srgbClr val="93C5FD"/>
                 </a:solidFill>
                 <a:latin typeface="Calibri" pitchFamily="34" charset="0"/>
                 <a:ea typeface="Calibri" pitchFamily="34" charset="-122"/>
@@ -2282,7 +2282,7 @@
             <a:r>
               <a:rPr lang="en-US" sz="850" dirty="0">
                 <a:solidFill>
-                  <a:srgbClr val="CADCFC"/>
+                  <a:srgbClr val="93C5FD"/>
                 </a:solidFill>
                 <a:latin typeface="Calibri" pitchFamily="34" charset="0"/>
                 <a:ea typeface="Calibri" pitchFamily="34" charset="-122"/>
@@ -2321,7 +2321,7 @@
             <a:r>
               <a:rPr lang="en-US" sz="800" dirty="0">
                 <a:solidFill>
-                  <a:srgbClr val="6B7280"/>
+                  <a:srgbClr val="64748B"/>
                 </a:solidFill>
                 <a:latin typeface="Consolas" pitchFamily="34" charset="0"/>
                 <a:ea typeface="Consolas" pitchFamily="34" charset="-122"/>
@@ -2360,7 +2360,7 @@
             <a:r>
               <a:rPr lang="en-US" sz="1000" dirty="0">
                 <a:solidFill>
-                  <a:srgbClr val="0070AD"/>
+                  <a:srgbClr val="2563EB"/>
                 </a:solidFill>
               </a:rPr>
               <a:t>▶</a:t>
@@ -2384,7 +2384,7 @@
             <a:avLst/>
           </a:prstGeom>
           <a:solidFill>
-            <a:srgbClr val="1E293B"/>
+            <a:srgbClr val="162032"/>
           </a:solidFill>
           <a:ln/>
           <a:effectLst>
@@ -2418,7 +2418,7 @@
             <a:avLst/>
           </a:prstGeom>
           <a:solidFill>
-            <a:srgbClr val="0891B2"/>
+            <a:srgbClr val="0EA5E9"/>
           </a:solidFill>
           <a:ln/>
         </p:spPr>
@@ -2445,7 +2445,7 @@
             <a:avLst/>
           </a:prstGeom>
           <a:solidFill>
-            <a:srgbClr val="0891B2"/>
+            <a:srgbClr val="0EA5E9"/>
           </a:solidFill>
           <a:ln/>
         </p:spPr>
@@ -2565,7 +2565,7 @@
             <a:r>
               <a:rPr lang="en-US" sz="850" dirty="0">
                 <a:solidFill>
-                  <a:srgbClr val="CADCFC"/>
+                  <a:srgbClr val="93C5FD"/>
                 </a:solidFill>
                 <a:latin typeface="Calibri" pitchFamily="34" charset="0"/>
                 <a:ea typeface="Calibri" pitchFamily="34" charset="-122"/>
@@ -2585,7 +2585,7 @@
             <a:r>
               <a:rPr lang="en-US" sz="850" dirty="0">
                 <a:solidFill>
-                  <a:srgbClr val="CADCFC"/>
+                  <a:srgbClr val="93C5FD"/>
                 </a:solidFill>
                 <a:latin typeface="Calibri" pitchFamily="34" charset="0"/>
                 <a:ea typeface="Calibri" pitchFamily="34" charset="-122"/>
@@ -2605,7 +2605,7 @@
             <a:r>
               <a:rPr lang="en-US" sz="850" dirty="0">
                 <a:solidFill>
-                  <a:srgbClr val="CADCFC"/>
+                  <a:srgbClr val="93C5FD"/>
                 </a:solidFill>
                 <a:latin typeface="Calibri" pitchFamily="34" charset="0"/>
                 <a:ea typeface="Calibri" pitchFamily="34" charset="-122"/>
@@ -2644,7 +2644,7 @@
             <a:r>
               <a:rPr lang="en-US" sz="800" dirty="0">
                 <a:solidFill>
-                  <a:srgbClr val="6B7280"/>
+                  <a:srgbClr val="64748B"/>
                 </a:solidFill>
                 <a:latin typeface="Consolas" pitchFamily="34" charset="0"/>
                 <a:ea typeface="Consolas" pitchFamily="34" charset="-122"/>
@@ -2683,7 +2683,7 @@
             <a:r>
               <a:rPr lang="en-US" sz="1000" dirty="0">
                 <a:solidFill>
-                  <a:srgbClr val="0070AD"/>
+                  <a:srgbClr val="2563EB"/>
                 </a:solidFill>
               </a:rPr>
               <a:t>▶</a:t>
@@ -2707,7 +2707,7 @@
             <a:avLst/>
           </a:prstGeom>
           <a:solidFill>
-            <a:srgbClr val="1E293B"/>
+            <a:srgbClr val="162032"/>
           </a:solidFill>
           <a:ln/>
           <a:effectLst>
@@ -2741,7 +2741,7 @@
             <a:avLst/>
           </a:prstGeom>
           <a:solidFill>
-            <a:srgbClr val="10B981"/>
+            <a:srgbClr val="14B8A6"/>
           </a:solidFill>
           <a:ln/>
         </p:spPr>
@@ -2768,7 +2768,7 @@
             <a:avLst/>
           </a:prstGeom>
           <a:solidFill>
-            <a:srgbClr val="10B981"/>
+            <a:srgbClr val="14B8A6"/>
           </a:solidFill>
           <a:ln/>
         </p:spPr>
@@ -2888,7 +2888,7 @@
             <a:r>
               <a:rPr lang="en-US" sz="850" dirty="0">
                 <a:solidFill>
-                  <a:srgbClr val="CADCFC"/>
+                  <a:srgbClr val="93C5FD"/>
                 </a:solidFill>
                 <a:latin typeface="Calibri" pitchFamily="34" charset="0"/>
                 <a:ea typeface="Calibri" pitchFamily="34" charset="-122"/>
@@ -2908,7 +2908,7 @@
             <a:r>
               <a:rPr lang="en-US" sz="850" dirty="0">
                 <a:solidFill>
-                  <a:srgbClr val="CADCFC"/>
+                  <a:srgbClr val="93C5FD"/>
                 </a:solidFill>
                 <a:latin typeface="Calibri" pitchFamily="34" charset="0"/>
                 <a:ea typeface="Calibri" pitchFamily="34" charset="-122"/>
@@ -2928,7 +2928,7 @@
             <a:r>
               <a:rPr lang="en-US" sz="850" dirty="0">
                 <a:solidFill>
-                  <a:srgbClr val="CADCFC"/>
+                  <a:srgbClr val="93C5FD"/>
                 </a:solidFill>
                 <a:latin typeface="Calibri" pitchFamily="34" charset="0"/>
                 <a:ea typeface="Calibri" pitchFamily="34" charset="-122"/>
@@ -2967,7 +2967,7 @@
             <a:r>
               <a:rPr lang="en-US" sz="800" dirty="0">
                 <a:solidFill>
-                  <a:srgbClr val="6B7280"/>
+                  <a:srgbClr val="64748B"/>
                 </a:solidFill>
                 <a:latin typeface="Consolas" pitchFamily="34" charset="0"/>
                 <a:ea typeface="Consolas" pitchFamily="34" charset="-122"/>
@@ -3006,7 +3006,7 @@
             <a:r>
               <a:rPr lang="en-US" sz="1000" dirty="0">
                 <a:solidFill>
-                  <a:srgbClr val="0070AD"/>
+                  <a:srgbClr val="2563EB"/>
                 </a:solidFill>
               </a:rPr>
               <a:t>▶</a:t>
@@ -3030,7 +3030,7 @@
             <a:avLst/>
           </a:prstGeom>
           <a:solidFill>
-            <a:srgbClr val="1E293B"/>
+            <a:srgbClr val="162032"/>
           </a:solidFill>
           <a:ln/>
           <a:effectLst>
@@ -3211,7 +3211,7 @@
             <a:r>
               <a:rPr lang="en-US" sz="850" dirty="0">
                 <a:solidFill>
-                  <a:srgbClr val="CADCFC"/>
+                  <a:srgbClr val="93C5FD"/>
                 </a:solidFill>
                 <a:latin typeface="Calibri" pitchFamily="34" charset="0"/>
                 <a:ea typeface="Calibri" pitchFamily="34" charset="-122"/>
@@ -3231,7 +3231,7 @@
             <a:r>
               <a:rPr lang="en-US" sz="850" dirty="0">
                 <a:solidFill>
-                  <a:srgbClr val="CADCFC"/>
+                  <a:srgbClr val="93C5FD"/>
                 </a:solidFill>
                 <a:latin typeface="Calibri" pitchFamily="34" charset="0"/>
                 <a:ea typeface="Calibri" pitchFamily="34" charset="-122"/>
@@ -3251,7 +3251,7 @@
             <a:r>
               <a:rPr lang="en-US" sz="850" dirty="0">
                 <a:solidFill>
-                  <a:srgbClr val="CADCFC"/>
+                  <a:srgbClr val="93C5FD"/>
                 </a:solidFill>
                 <a:latin typeface="Calibri" pitchFamily="34" charset="0"/>
                 <a:ea typeface="Calibri" pitchFamily="34" charset="-122"/>
@@ -3290,7 +3290,7 @@
             <a:r>
               <a:rPr lang="en-US" sz="800" dirty="0">
                 <a:solidFill>
-                  <a:srgbClr val="6B7280"/>
+                  <a:srgbClr val="64748B"/>
                 </a:solidFill>
                 <a:latin typeface="Consolas" pitchFamily="34" charset="0"/>
                 <a:ea typeface="Consolas" pitchFamily="34" charset="-122"/>
@@ -3329,7 +3329,7 @@
             <a:r>
               <a:rPr lang="en-US" sz="1000" dirty="0">
                 <a:solidFill>
-                  <a:srgbClr val="0070AD"/>
+                  <a:srgbClr val="2563EB"/>
                 </a:solidFill>
               </a:rPr>
               <a:t>▶</a:t>
@@ -3353,7 +3353,7 @@
             <a:avLst/>
           </a:prstGeom>
           <a:solidFill>
-            <a:srgbClr val="1E293B"/>
+            <a:srgbClr val="162032"/>
           </a:solidFill>
           <a:ln/>
           <a:effectLst>
@@ -3387,7 +3387,7 @@
             <a:avLst/>
           </a:prstGeom>
           <a:solidFill>
-            <a:srgbClr val="7C3AED"/>
+            <a:srgbClr val="6366F1"/>
           </a:solidFill>
           <a:ln/>
         </p:spPr>
@@ -3414,7 +3414,7 @@
             <a:avLst/>
           </a:prstGeom>
           <a:solidFill>
-            <a:srgbClr val="7C3AED"/>
+            <a:srgbClr val="6366F1"/>
           </a:solidFill>
           <a:ln/>
         </p:spPr>
@@ -3534,7 +3534,7 @@
             <a:r>
               <a:rPr lang="en-US" sz="850" dirty="0">
                 <a:solidFill>
-                  <a:srgbClr val="CADCFC"/>
+                  <a:srgbClr val="93C5FD"/>
                 </a:solidFill>
                 <a:latin typeface="Calibri" pitchFamily="34" charset="0"/>
                 <a:ea typeface="Calibri" pitchFamily="34" charset="-122"/>
@@ -3554,7 +3554,7 @@
             <a:r>
               <a:rPr lang="en-US" sz="850" dirty="0">
                 <a:solidFill>
-                  <a:srgbClr val="CADCFC"/>
+                  <a:srgbClr val="93C5FD"/>
                 </a:solidFill>
                 <a:latin typeface="Calibri" pitchFamily="34" charset="0"/>
                 <a:ea typeface="Calibri" pitchFamily="34" charset="-122"/>
@@ -3574,7 +3574,7 @@
             <a:r>
               <a:rPr lang="en-US" sz="850" dirty="0">
                 <a:solidFill>
-                  <a:srgbClr val="CADCFC"/>
+                  <a:srgbClr val="93C5FD"/>
                 </a:solidFill>
                 <a:latin typeface="Calibri" pitchFamily="34" charset="0"/>
                 <a:ea typeface="Calibri" pitchFamily="34" charset="-122"/>
@@ -3613,7 +3613,7 @@
             <a:r>
               <a:rPr lang="en-US" sz="800" dirty="0">
                 <a:solidFill>
-                  <a:srgbClr val="6B7280"/>
+                  <a:srgbClr val="64748B"/>
                 </a:solidFill>
                 <a:latin typeface="Consolas" pitchFamily="34" charset="0"/>
                 <a:ea typeface="Consolas" pitchFamily="34" charset="-122"/>
@@ -3652,7 +3652,7 @@
             <a:r>
               <a:rPr lang="en-US" sz="1000" dirty="0">
                 <a:solidFill>
-                  <a:srgbClr val="0070AD"/>
+                  <a:srgbClr val="2563EB"/>
                 </a:solidFill>
               </a:rPr>
               <a:t>▶</a:t>
@@ -3676,7 +3676,7 @@
             <a:avLst/>
           </a:prstGeom>
           <a:solidFill>
-            <a:srgbClr val="1E293B"/>
+            <a:srgbClr val="162032"/>
           </a:solidFill>
           <a:ln/>
           <a:effectLst>
@@ -3857,7 +3857,7 @@
             <a:r>
               <a:rPr lang="en-US" sz="850" dirty="0">
                 <a:solidFill>
-                  <a:srgbClr val="CADCFC"/>
+                  <a:srgbClr val="93C5FD"/>
                 </a:solidFill>
                 <a:latin typeface="Calibri" pitchFamily="34" charset="0"/>
                 <a:ea typeface="Calibri" pitchFamily="34" charset="-122"/>
@@ -3877,7 +3877,7 @@
             <a:r>
               <a:rPr lang="en-US" sz="850" dirty="0">
                 <a:solidFill>
-                  <a:srgbClr val="CADCFC"/>
+                  <a:srgbClr val="93C5FD"/>
                 </a:solidFill>
                 <a:latin typeface="Calibri" pitchFamily="34" charset="0"/>
                 <a:ea typeface="Calibri" pitchFamily="34" charset="-122"/>
@@ -3897,7 +3897,7 @@
             <a:r>
               <a:rPr lang="en-US" sz="850" dirty="0">
                 <a:solidFill>
-                  <a:srgbClr val="CADCFC"/>
+                  <a:srgbClr val="93C5FD"/>
                 </a:solidFill>
                 <a:latin typeface="Calibri" pitchFamily="34" charset="0"/>
                 <a:ea typeface="Calibri" pitchFamily="34" charset="-122"/>
@@ -3936,7 +3936,7 @@
             <a:r>
               <a:rPr lang="en-US" sz="800" dirty="0">
                 <a:solidFill>
-                  <a:srgbClr val="6B7280"/>
+                  <a:srgbClr val="64748B"/>
                 </a:solidFill>
                 <a:latin typeface="Consolas" pitchFamily="34" charset="0"/>
                 <a:ea typeface="Consolas" pitchFamily="34" charset="-122"/>
@@ -3975,7 +3975,7 @@
             <a:r>
               <a:rPr lang="en-US" sz="900" dirty="0">
                 <a:solidFill>
-                  <a:srgbClr val="6B7280"/>
+                  <a:srgbClr val="64748B"/>
                 </a:solidFill>
                 <a:latin typeface="Calibri" pitchFamily="34" charset="0"/>
                 <a:ea typeface="Calibri" pitchFamily="34" charset="-122"/>
@@ -4002,13 +4002,13 @@
             <a:avLst/>
           </a:prstGeom>
           <a:solidFill>
-            <a:srgbClr val="0070AD">
+            <a:srgbClr val="2563EB">
               <a:alpha val="30000"/>
             </a:srgbClr>
           </a:solidFill>
           <a:ln w="12700">
             <a:solidFill>
-              <a:srgbClr val="0070AD"/>
+              <a:srgbClr val="2563EB"/>
             </a:solidFill>
             <a:prstDash val="solid"/>
           </a:ln>
@@ -4048,7 +4048,7 @@
             <a:r>
               <a:rPr lang="en-US" sz="1000" b="1" dirty="0">
                 <a:solidFill>
-                  <a:srgbClr val="CADCFC"/>
+                  <a:srgbClr val="93C5FD"/>
                 </a:solidFill>
                 <a:latin typeface="Calibri" pitchFamily="34" charset="0"/>
                 <a:ea typeface="Calibri" pitchFamily="34" charset="-122"/>
@@ -4075,13 +4075,13 @@
             <a:avLst/>
           </a:prstGeom>
           <a:solidFill>
-            <a:srgbClr val="0070AD">
+            <a:srgbClr val="2563EB">
               <a:alpha val="30000"/>
             </a:srgbClr>
           </a:solidFill>
           <a:ln w="12700">
             <a:solidFill>
-              <a:srgbClr val="0070AD"/>
+              <a:srgbClr val="2563EB"/>
             </a:solidFill>
             <a:prstDash val="solid"/>
           </a:ln>
@@ -4121,7 +4121,7 @@
             <a:r>
               <a:rPr lang="en-US" sz="1000" b="1" dirty="0">
                 <a:solidFill>
-                  <a:srgbClr val="CADCFC"/>
+                  <a:srgbClr val="93C5FD"/>
                 </a:solidFill>
                 <a:latin typeface="Calibri" pitchFamily="34" charset="0"/>
                 <a:ea typeface="Calibri" pitchFamily="34" charset="-122"/>
@@ -4148,13 +4148,13 @@
             <a:avLst/>
           </a:prstGeom>
           <a:solidFill>
-            <a:srgbClr val="0070AD">
+            <a:srgbClr val="2563EB">
               <a:alpha val="30000"/>
             </a:srgbClr>
           </a:solidFill>
           <a:ln w="12700">
             <a:solidFill>
-              <a:srgbClr val="0070AD"/>
+              <a:srgbClr val="2563EB"/>
             </a:solidFill>
             <a:prstDash val="solid"/>
           </a:ln>
@@ -4194,7 +4194,7 @@
             <a:r>
               <a:rPr lang="en-US" sz="1000" b="1" dirty="0">
                 <a:solidFill>
-                  <a:srgbClr val="CADCFC"/>
+                  <a:srgbClr val="93C5FD"/>
                 </a:solidFill>
                 <a:latin typeface="Calibri" pitchFamily="34" charset="0"/>
                 <a:ea typeface="Calibri" pitchFamily="34" charset="-122"/>
@@ -4221,13 +4221,13 @@
             <a:avLst/>
           </a:prstGeom>
           <a:solidFill>
-            <a:srgbClr val="0070AD">
+            <a:srgbClr val="2563EB">
               <a:alpha val="30000"/>
             </a:srgbClr>
           </a:solidFill>
           <a:ln w="12700">
             <a:solidFill>
-              <a:srgbClr val="0070AD"/>
+              <a:srgbClr val="2563EB"/>
             </a:solidFill>
             <a:prstDash val="solid"/>
           </a:ln>
@@ -4267,7 +4267,7 @@
             <a:r>
               <a:rPr lang="en-US" sz="1000" b="1" dirty="0">
                 <a:solidFill>
-                  <a:srgbClr val="CADCFC"/>
+                  <a:srgbClr val="93C5FD"/>
                 </a:solidFill>
                 <a:latin typeface="Calibri" pitchFamily="34" charset="0"/>
                 <a:ea typeface="Calibri" pitchFamily="34" charset="-122"/>
@@ -4293,7 +4293,7 @@
     <p:bg>
       <p:bgPr>
         <a:solidFill>
-          <a:srgbClr val="0F1F3D"/>
+          <a:srgbClr val="0B1A33"/>
         </a:solidFill>
         <a:effectLst/>
       </p:bgPr>
@@ -4327,7 +4327,7 @@
             <a:avLst/>
           </a:prstGeom>
           <a:solidFill>
-            <a:srgbClr val="0070AD"/>
+            <a:srgbClr val="2563EB"/>
           </a:solidFill>
           <a:ln/>
         </p:spPr>
@@ -4405,7 +4405,7 @@
             <a:r>
               <a:rPr lang="en-US" sz="1300" dirty="0">
                 <a:solidFill>
-                  <a:srgbClr val="CADCFC"/>
+                  <a:srgbClr val="93C5FD"/>
                 </a:solidFill>
                 <a:latin typeface="Calibri" pitchFamily="34" charset="0"/>
                 <a:ea typeface="Calibri" pitchFamily="34" charset="-122"/>
@@ -4466,7 +4466,7 @@
             <a:avLst/>
           </a:prstGeom>
           <a:solidFill>
-            <a:srgbClr val="0070AD"/>
+            <a:srgbClr val="2563EB"/>
           </a:solidFill>
           <a:ln/>
         </p:spPr>
@@ -4493,7 +4493,7 @@
             <a:avLst/>
           </a:prstGeom>
           <a:solidFill>
-            <a:srgbClr val="0070AD"/>
+            <a:srgbClr val="2563EB"/>
           </a:solidFill>
           <a:ln/>
         </p:spPr>
@@ -4571,7 +4571,7 @@
             <a:r>
               <a:rPr lang="en-US" sz="1300" b="1" dirty="0">
                 <a:solidFill>
-                  <a:srgbClr val="1B365D"/>
+                  <a:srgbClr val="1E3A5F"/>
                 </a:solidFill>
                 <a:latin typeface="Calibri" pitchFamily="34" charset="0"/>
                 <a:ea typeface="Calibri" pitchFamily="34" charset="-122"/>
@@ -4613,7 +4613,7 @@
             <a:r>
               <a:rPr lang="en-US" sz="950" dirty="0">
                 <a:solidFill>
-                  <a:srgbClr val="374151"/>
+                  <a:srgbClr val="334155"/>
                 </a:solidFill>
                 <a:latin typeface="Calibri" pitchFamily="34" charset="0"/>
                 <a:ea typeface="Calibri" pitchFamily="34" charset="-122"/>
@@ -4633,7 +4633,7 @@
             <a:r>
               <a:rPr lang="en-US" sz="950" dirty="0">
                 <a:solidFill>
-                  <a:srgbClr val="374151"/>
+                  <a:srgbClr val="334155"/>
                 </a:solidFill>
                 <a:latin typeface="Calibri" pitchFamily="34" charset="0"/>
                 <a:ea typeface="Calibri" pitchFamily="34" charset="-122"/>
@@ -4653,7 +4653,7 @@
             <a:r>
               <a:rPr lang="en-US" sz="950" dirty="0">
                 <a:solidFill>
-                  <a:srgbClr val="374151"/>
+                  <a:srgbClr val="334155"/>
                 </a:solidFill>
                 <a:latin typeface="Calibri" pitchFamily="34" charset="0"/>
                 <a:ea typeface="Calibri" pitchFamily="34" charset="-122"/>
@@ -4714,7 +4714,7 @@
             <a:avLst/>
           </a:prstGeom>
           <a:solidFill>
-            <a:srgbClr val="0891B2"/>
+            <a:srgbClr val="0EA5E9"/>
           </a:solidFill>
           <a:ln/>
         </p:spPr>
@@ -4741,7 +4741,7 @@
             <a:avLst/>
           </a:prstGeom>
           <a:solidFill>
-            <a:srgbClr val="0891B2"/>
+            <a:srgbClr val="0EA5E9"/>
           </a:solidFill>
           <a:ln/>
         </p:spPr>
@@ -4819,7 +4819,7 @@
             <a:r>
               <a:rPr lang="en-US" sz="1300" b="1" dirty="0">
                 <a:solidFill>
-                  <a:srgbClr val="1B365D"/>
+                  <a:srgbClr val="1E3A5F"/>
                 </a:solidFill>
                 <a:latin typeface="Calibri" pitchFamily="34" charset="0"/>
                 <a:ea typeface="Calibri" pitchFamily="34" charset="-122"/>
@@ -4861,7 +4861,7 @@
             <a:r>
               <a:rPr lang="en-US" sz="950" dirty="0">
                 <a:solidFill>
-                  <a:srgbClr val="374151"/>
+                  <a:srgbClr val="334155"/>
                 </a:solidFill>
                 <a:latin typeface="Calibri" pitchFamily="34" charset="0"/>
                 <a:ea typeface="Calibri" pitchFamily="34" charset="-122"/>
@@ -4881,7 +4881,7 @@
             <a:r>
               <a:rPr lang="en-US" sz="950" dirty="0">
                 <a:solidFill>
-                  <a:srgbClr val="374151"/>
+                  <a:srgbClr val="334155"/>
                 </a:solidFill>
                 <a:latin typeface="Calibri" pitchFamily="34" charset="0"/>
                 <a:ea typeface="Calibri" pitchFamily="34" charset="-122"/>
@@ -4901,7 +4901,7 @@
             <a:r>
               <a:rPr lang="en-US" sz="950" dirty="0">
                 <a:solidFill>
-                  <a:srgbClr val="374151"/>
+                  <a:srgbClr val="334155"/>
                 </a:solidFill>
                 <a:latin typeface="Calibri" pitchFamily="34" charset="0"/>
                 <a:ea typeface="Calibri" pitchFamily="34" charset="-122"/>
@@ -4962,7 +4962,7 @@
             <a:avLst/>
           </a:prstGeom>
           <a:solidFill>
-            <a:srgbClr val="10B981"/>
+            <a:srgbClr val="14B8A6"/>
           </a:solidFill>
           <a:ln/>
         </p:spPr>
@@ -4989,7 +4989,7 @@
             <a:avLst/>
           </a:prstGeom>
           <a:solidFill>
-            <a:srgbClr val="10B981"/>
+            <a:srgbClr val="14B8A6"/>
           </a:solidFill>
           <a:ln/>
         </p:spPr>
@@ -5067,7 +5067,7 @@
             <a:r>
               <a:rPr lang="en-US" sz="1300" b="1" dirty="0">
                 <a:solidFill>
-                  <a:srgbClr val="1B365D"/>
+                  <a:srgbClr val="1E3A5F"/>
                 </a:solidFill>
                 <a:latin typeface="Calibri" pitchFamily="34" charset="0"/>
                 <a:ea typeface="Calibri" pitchFamily="34" charset="-122"/>
@@ -5109,7 +5109,7 @@
             <a:r>
               <a:rPr lang="en-US" sz="950" dirty="0">
                 <a:solidFill>
-                  <a:srgbClr val="374151"/>
+                  <a:srgbClr val="334155"/>
                 </a:solidFill>
                 <a:latin typeface="Calibri" pitchFamily="34" charset="0"/>
                 <a:ea typeface="Calibri" pitchFamily="34" charset="-122"/>
@@ -5129,7 +5129,7 @@
             <a:r>
               <a:rPr lang="en-US" sz="950" dirty="0">
                 <a:solidFill>
-                  <a:srgbClr val="374151"/>
+                  <a:srgbClr val="334155"/>
                 </a:solidFill>
                 <a:latin typeface="Calibri" pitchFamily="34" charset="0"/>
                 <a:ea typeface="Calibri" pitchFamily="34" charset="-122"/>
@@ -5149,7 +5149,7 @@
             <a:r>
               <a:rPr lang="en-US" sz="950" dirty="0">
                 <a:solidFill>
-                  <a:srgbClr val="374151"/>
+                  <a:srgbClr val="334155"/>
                 </a:solidFill>
                 <a:latin typeface="Calibri" pitchFamily="34" charset="0"/>
                 <a:ea typeface="Calibri" pitchFamily="34" charset="-122"/>
@@ -5315,7 +5315,7 @@
             <a:r>
               <a:rPr lang="en-US" sz="1300" b="1" dirty="0">
                 <a:solidFill>
-                  <a:srgbClr val="1B365D"/>
+                  <a:srgbClr val="1E3A5F"/>
                 </a:solidFill>
                 <a:latin typeface="Calibri" pitchFamily="34" charset="0"/>
                 <a:ea typeface="Calibri" pitchFamily="34" charset="-122"/>
@@ -5357,7 +5357,7 @@
             <a:r>
               <a:rPr lang="en-US" sz="950" dirty="0">
                 <a:solidFill>
-                  <a:srgbClr val="374151"/>
+                  <a:srgbClr val="334155"/>
                 </a:solidFill>
                 <a:latin typeface="Calibri" pitchFamily="34" charset="0"/>
                 <a:ea typeface="Calibri" pitchFamily="34" charset="-122"/>
@@ -5377,7 +5377,7 @@
             <a:r>
               <a:rPr lang="en-US" sz="950" dirty="0">
                 <a:solidFill>
-                  <a:srgbClr val="374151"/>
+                  <a:srgbClr val="334155"/>
                 </a:solidFill>
                 <a:latin typeface="Calibri" pitchFamily="34" charset="0"/>
                 <a:ea typeface="Calibri" pitchFamily="34" charset="-122"/>
@@ -5397,7 +5397,7 @@
             <a:r>
               <a:rPr lang="en-US" sz="950" dirty="0">
                 <a:solidFill>
-                  <a:srgbClr val="374151"/>
+                  <a:srgbClr val="334155"/>
                 </a:solidFill>
                 <a:latin typeface="Calibri" pitchFamily="34" charset="0"/>
                 <a:ea typeface="Calibri" pitchFamily="34" charset="-122"/>
@@ -5458,7 +5458,7 @@
             <a:avLst/>
           </a:prstGeom>
           <a:solidFill>
-            <a:srgbClr val="7C3AED"/>
+            <a:srgbClr val="6366F1"/>
           </a:solidFill>
           <a:ln/>
         </p:spPr>
@@ -5485,7 +5485,7 @@
             <a:avLst/>
           </a:prstGeom>
           <a:solidFill>
-            <a:srgbClr val="7C3AED"/>
+            <a:srgbClr val="6366F1"/>
           </a:solidFill>
           <a:ln/>
         </p:spPr>
@@ -5563,7 +5563,7 @@
             <a:r>
               <a:rPr lang="en-US" sz="1300" b="1" dirty="0">
                 <a:solidFill>
-                  <a:srgbClr val="1B365D"/>
+                  <a:srgbClr val="1E3A5F"/>
                 </a:solidFill>
                 <a:latin typeface="Calibri" pitchFamily="34" charset="0"/>
                 <a:ea typeface="Calibri" pitchFamily="34" charset="-122"/>
@@ -5605,7 +5605,7 @@
             <a:r>
               <a:rPr lang="en-US" sz="950" dirty="0">
                 <a:solidFill>
-                  <a:srgbClr val="374151"/>
+                  <a:srgbClr val="334155"/>
                 </a:solidFill>
                 <a:latin typeface="Calibri" pitchFamily="34" charset="0"/>
                 <a:ea typeface="Calibri" pitchFamily="34" charset="-122"/>
@@ -5625,7 +5625,7 @@
             <a:r>
               <a:rPr lang="en-US" sz="950" dirty="0">
                 <a:solidFill>
-                  <a:srgbClr val="374151"/>
+                  <a:srgbClr val="334155"/>
                 </a:solidFill>
                 <a:latin typeface="Calibri" pitchFamily="34" charset="0"/>
                 <a:ea typeface="Calibri" pitchFamily="34" charset="-122"/>
@@ -5645,7 +5645,7 @@
             <a:r>
               <a:rPr lang="en-US" sz="950" dirty="0">
                 <a:solidFill>
-                  <a:srgbClr val="374151"/>
+                  <a:srgbClr val="334155"/>
                 </a:solidFill>
                 <a:latin typeface="Calibri" pitchFamily="34" charset="0"/>
                 <a:ea typeface="Calibri" pitchFamily="34" charset="-122"/>
@@ -5811,7 +5811,7 @@
             <a:r>
               <a:rPr lang="en-US" sz="1300" b="1" dirty="0">
                 <a:solidFill>
-                  <a:srgbClr val="1B365D"/>
+                  <a:srgbClr val="1E3A5F"/>
                 </a:solidFill>
                 <a:latin typeface="Calibri" pitchFamily="34" charset="0"/>
                 <a:ea typeface="Calibri" pitchFamily="34" charset="-122"/>
@@ -5853,7 +5853,7 @@
             <a:r>
               <a:rPr lang="en-US" sz="950" dirty="0">
                 <a:solidFill>
-                  <a:srgbClr val="374151"/>
+                  <a:srgbClr val="334155"/>
                 </a:solidFill>
                 <a:latin typeface="Calibri" pitchFamily="34" charset="0"/>
                 <a:ea typeface="Calibri" pitchFamily="34" charset="-122"/>
@@ -5873,7 +5873,7 @@
             <a:r>
               <a:rPr lang="en-US" sz="950" dirty="0">
                 <a:solidFill>
-                  <a:srgbClr val="374151"/>
+                  <a:srgbClr val="334155"/>
                 </a:solidFill>
                 <a:latin typeface="Calibri" pitchFamily="34" charset="0"/>
                 <a:ea typeface="Calibri" pitchFamily="34" charset="-122"/>
@@ -5893,7 +5893,7 @@
             <a:r>
               <a:rPr lang="en-US" sz="950" dirty="0">
                 <a:solidFill>
-                  <a:srgbClr val="374151"/>
+                  <a:srgbClr val="334155"/>
                 </a:solidFill>
                 <a:latin typeface="Calibri" pitchFamily="34" charset="0"/>
                 <a:ea typeface="Calibri" pitchFamily="34" charset="-122"/>
@@ -5932,7 +5932,7 @@
             <a:r>
               <a:rPr lang="en-US" sz="900" dirty="0">
                 <a:solidFill>
-                  <a:srgbClr val="6B7280"/>
+                  <a:srgbClr val="64748B"/>
                 </a:solidFill>
                 <a:latin typeface="Calibri" pitchFamily="34" charset="0"/>
                 <a:ea typeface="Calibri" pitchFamily="34" charset="-122"/>
@@ -5958,7 +5958,7 @@
     <p:bg>
       <p:bgPr>
         <a:solidFill>
-          <a:srgbClr val="F5F7FA"/>
+          <a:srgbClr val="EFF6FF"/>
         </a:solidFill>
         <a:effectLst/>
       </p:bgPr>
@@ -5992,7 +5992,7 @@
             <a:avLst/>
           </a:prstGeom>
           <a:solidFill>
-            <a:srgbClr val="0070AD"/>
+            <a:srgbClr val="2563EB"/>
           </a:solidFill>
           <a:ln/>
         </p:spPr>
@@ -6031,7 +6031,7 @@
             <a:r>
               <a:rPr lang="en-US" sz="2800" b="1" dirty="0">
                 <a:solidFill>
-                  <a:srgbClr val="1B365D"/>
+                  <a:srgbClr val="1E3A5F"/>
                 </a:solidFill>
                 <a:latin typeface="Calibri" pitchFamily="34" charset="0"/>
                 <a:ea typeface="Calibri" pitchFamily="34" charset="-122"/>
@@ -6070,7 +6070,7 @@
             <a:r>
               <a:rPr lang="en-US" sz="1300" dirty="0">
                 <a:solidFill>
-                  <a:srgbClr val="6B7280"/>
+                  <a:srgbClr val="64748B"/>
                 </a:solidFill>
                 <a:latin typeface="Calibri" pitchFamily="34" charset="0"/>
                 <a:ea typeface="Calibri" pitchFamily="34" charset="-122"/>
@@ -6131,7 +6131,7 @@
             <a:avLst/>
           </a:prstGeom>
           <a:solidFill>
-            <a:srgbClr val="0070AD"/>
+            <a:srgbClr val="2563EB"/>
           </a:solidFill>
           <a:ln/>
         </p:spPr>
@@ -6170,7 +6170,7 @@
             <a:r>
               <a:rPr lang="en-US" sz="1200" b="1" dirty="0">
                 <a:solidFill>
-                  <a:srgbClr val="1B365D"/>
+                  <a:srgbClr val="1E3A5F"/>
                 </a:solidFill>
                 <a:latin typeface="Calibri" pitchFamily="34" charset="0"/>
                 <a:ea typeface="Calibri" pitchFamily="34" charset="-122"/>
@@ -6197,7 +6197,7 @@
             <a:avLst/>
           </a:prstGeom>
           <a:solidFill>
-            <a:srgbClr val="0070AD"/>
+            <a:srgbClr val="2563EB"/>
           </a:solidFill>
           <a:ln/>
         </p:spPr>
@@ -6236,7 +6236,7 @@
             <a:r>
               <a:rPr lang="en-US" sz="1000" b="1" dirty="0">
                 <a:solidFill>
-                  <a:srgbClr val="1B365D"/>
+                  <a:srgbClr val="1E3A5F"/>
                 </a:solidFill>
                 <a:latin typeface="Calibri" pitchFamily="34" charset="0"/>
                 <a:ea typeface="Calibri" pitchFamily="34" charset="-122"/>
@@ -6278,7 +6278,7 @@
             <a:r>
               <a:rPr lang="en-US" sz="850" dirty="0">
                 <a:solidFill>
-                  <a:srgbClr val="374151"/>
+                  <a:srgbClr val="334155"/>
                 </a:solidFill>
                 <a:latin typeface="Calibri" pitchFamily="34" charset="0"/>
                 <a:ea typeface="Calibri" pitchFamily="34" charset="-122"/>
@@ -6298,7 +6298,7 @@
             <a:r>
               <a:rPr lang="en-US" sz="850" dirty="0">
                 <a:solidFill>
-                  <a:srgbClr val="374151"/>
+                  <a:srgbClr val="334155"/>
                 </a:solidFill>
                 <a:latin typeface="Calibri" pitchFamily="34" charset="0"/>
                 <a:ea typeface="Calibri" pitchFamily="34" charset="-122"/>
@@ -6327,7 +6327,7 @@
           <a:noFill/>
           <a:ln w="19050">
             <a:solidFill>
-              <a:srgbClr val="CADCFC"/>
+              <a:srgbClr val="93C5FD"/>
             </a:solidFill>
             <a:prstDash val="solid"/>
           </a:ln>
@@ -6355,7 +6355,7 @@
             <a:avLst/>
           </a:prstGeom>
           <a:solidFill>
-            <a:srgbClr val="0070AD"/>
+            <a:srgbClr val="2563EB"/>
           </a:solidFill>
           <a:ln/>
         </p:spPr>
@@ -6394,7 +6394,7 @@
             <a:r>
               <a:rPr lang="en-US" sz="1000" b="1" dirty="0">
                 <a:solidFill>
-                  <a:srgbClr val="1B365D"/>
+                  <a:srgbClr val="1E3A5F"/>
                 </a:solidFill>
                 <a:latin typeface="Calibri" pitchFamily="34" charset="0"/>
                 <a:ea typeface="Calibri" pitchFamily="34" charset="-122"/>
@@ -6436,7 +6436,7 @@
             <a:r>
               <a:rPr lang="en-US" sz="850" dirty="0">
                 <a:solidFill>
-                  <a:srgbClr val="374151"/>
+                  <a:srgbClr val="334155"/>
                 </a:solidFill>
                 <a:latin typeface="Calibri" pitchFamily="34" charset="0"/>
                 <a:ea typeface="Calibri" pitchFamily="34" charset="-122"/>
@@ -6456,7 +6456,7 @@
             <a:r>
               <a:rPr lang="en-US" sz="850" dirty="0">
                 <a:solidFill>
-                  <a:srgbClr val="374151"/>
+                  <a:srgbClr val="334155"/>
                 </a:solidFill>
                 <a:latin typeface="Calibri" pitchFamily="34" charset="0"/>
                 <a:ea typeface="Calibri" pitchFamily="34" charset="-122"/>
@@ -6485,7 +6485,7 @@
           <a:noFill/>
           <a:ln w="19050">
             <a:solidFill>
-              <a:srgbClr val="CADCFC"/>
+              <a:srgbClr val="93C5FD"/>
             </a:solidFill>
             <a:prstDash val="solid"/>
           </a:ln>
@@ -6513,7 +6513,7 @@
             <a:avLst/>
           </a:prstGeom>
           <a:solidFill>
-            <a:srgbClr val="0070AD"/>
+            <a:srgbClr val="2563EB"/>
           </a:solidFill>
           <a:ln/>
         </p:spPr>
@@ -6552,7 +6552,7 @@
             <a:r>
               <a:rPr lang="en-US" sz="1000" b="1" dirty="0">
                 <a:solidFill>
-                  <a:srgbClr val="1B365D"/>
+                  <a:srgbClr val="1E3A5F"/>
                 </a:solidFill>
                 <a:latin typeface="Calibri" pitchFamily="34" charset="0"/>
                 <a:ea typeface="Calibri" pitchFamily="34" charset="-122"/>
@@ -6594,7 +6594,7 @@
             <a:r>
               <a:rPr lang="en-US" sz="850" dirty="0">
                 <a:solidFill>
-                  <a:srgbClr val="374151"/>
+                  <a:srgbClr val="334155"/>
                 </a:solidFill>
                 <a:latin typeface="Calibri" pitchFamily="34" charset="0"/>
                 <a:ea typeface="Calibri" pitchFamily="34" charset="-122"/>
@@ -6614,7 +6614,7 @@
             <a:r>
               <a:rPr lang="en-US" sz="850" dirty="0">
                 <a:solidFill>
-                  <a:srgbClr val="374151"/>
+                  <a:srgbClr val="334155"/>
                 </a:solidFill>
                 <a:latin typeface="Calibri" pitchFamily="34" charset="0"/>
                 <a:ea typeface="Calibri" pitchFamily="34" charset="-122"/>
@@ -6643,7 +6643,7 @@
           <a:noFill/>
           <a:ln w="19050">
             <a:solidFill>
-              <a:srgbClr val="CADCFC"/>
+              <a:srgbClr val="93C5FD"/>
             </a:solidFill>
             <a:prstDash val="solid"/>
           </a:ln>
@@ -6671,7 +6671,7 @@
             <a:avLst/>
           </a:prstGeom>
           <a:solidFill>
-            <a:srgbClr val="0070AD"/>
+            <a:srgbClr val="2563EB"/>
           </a:solidFill>
           <a:ln/>
         </p:spPr>
@@ -6710,7 +6710,7 @@
             <a:r>
               <a:rPr lang="en-US" sz="1000" b="1" dirty="0">
                 <a:solidFill>
-                  <a:srgbClr val="1B365D"/>
+                  <a:srgbClr val="1E3A5F"/>
                 </a:solidFill>
                 <a:latin typeface="Calibri" pitchFamily="34" charset="0"/>
                 <a:ea typeface="Calibri" pitchFamily="34" charset="-122"/>
@@ -6752,7 +6752,7 @@
             <a:r>
               <a:rPr lang="en-US" sz="850" dirty="0">
                 <a:solidFill>
-                  <a:srgbClr val="374151"/>
+                  <a:srgbClr val="334155"/>
                 </a:solidFill>
                 <a:latin typeface="Calibri" pitchFamily="34" charset="0"/>
                 <a:ea typeface="Calibri" pitchFamily="34" charset="-122"/>
@@ -6772,18 +6772,18 @@
             <a:r>
               <a:rPr lang="en-US" sz="850" dirty="0">
                 <a:solidFill>
-                  <a:srgbClr val="374151"/>
-                </a:solidFill>
-                <a:latin typeface="Calibri" pitchFamily="34" charset="0"/>
-                <a:ea typeface="Calibri" pitchFamily="34" charset="-122"/>
-                <a:cs typeface="Calibri" pitchFamily="34" charset="-120"/>
-              </a:rPr>
-              <a:t>Handles unknown connectors and enhance the converted one’s </a:t>
+                  <a:srgbClr val="334155"/>
+                </a:solidFill>
+                <a:latin typeface="Calibri" pitchFamily="34" charset="0"/>
+                <a:ea typeface="Calibri" pitchFamily="34" charset="-122"/>
+                <a:cs typeface="Calibri" pitchFamily="34" charset="-120"/>
+              </a:rPr>
+              <a:t xml:space="preserve">Handles unknown connectors and enhance the converted one’s </a:t>
             </a:r>
             <a:r>
               <a:rPr lang="en-US" sz="850" dirty="0" err="1">
                 <a:solidFill>
-                  <a:srgbClr val="374151"/>
+                  <a:srgbClr val="334155"/>
                 </a:solidFill>
                 <a:latin typeface="Calibri" pitchFamily="34" charset="0"/>
                 <a:ea typeface="Calibri" pitchFamily="34" charset="-122"/>
@@ -6794,7 +6794,7 @@
             <a:r>
               <a:rPr lang="en-US" sz="850" dirty="0">
                 <a:solidFill>
-                  <a:srgbClr val="374151"/>
+                  <a:srgbClr val="334155"/>
                 </a:solidFill>
                 <a:latin typeface="Calibri" pitchFamily="34" charset="0"/>
                 <a:ea typeface="Calibri" pitchFamily="34" charset="-122"/>
@@ -6823,7 +6823,7 @@
           <a:noFill/>
           <a:ln w="19050">
             <a:solidFill>
-              <a:srgbClr val="CADCFC"/>
+              <a:srgbClr val="93C5FD"/>
             </a:solidFill>
             <a:prstDash val="solid"/>
           </a:ln>
@@ -6851,7 +6851,7 @@
             <a:avLst/>
           </a:prstGeom>
           <a:solidFill>
-            <a:srgbClr val="0070AD"/>
+            <a:srgbClr val="2563EB"/>
           </a:solidFill>
           <a:ln/>
         </p:spPr>
@@ -6890,7 +6890,7 @@
             <a:r>
               <a:rPr lang="en-US" sz="1000" b="1" dirty="0">
                 <a:solidFill>
-                  <a:srgbClr val="1B365D"/>
+                  <a:srgbClr val="1E3A5F"/>
                 </a:solidFill>
                 <a:latin typeface="Calibri" pitchFamily="34" charset="0"/>
                 <a:ea typeface="Calibri" pitchFamily="34" charset="-122"/>
@@ -6932,7 +6932,7 @@
             <a:r>
               <a:rPr lang="en-US" sz="850" dirty="0">
                 <a:solidFill>
-                  <a:srgbClr val="374151"/>
+                  <a:srgbClr val="334155"/>
                 </a:solidFill>
                 <a:latin typeface="Calibri" pitchFamily="34" charset="0"/>
                 <a:ea typeface="Calibri" pitchFamily="34" charset="-122"/>
@@ -6952,7 +6952,7 @@
             <a:r>
               <a:rPr lang="en-US" sz="850" dirty="0">
                 <a:solidFill>
-                  <a:srgbClr val="374151"/>
+                  <a:srgbClr val="334155"/>
                 </a:solidFill>
                 <a:latin typeface="Calibri" pitchFamily="34" charset="0"/>
                 <a:ea typeface="Calibri" pitchFamily="34" charset="-122"/>
@@ -6981,7 +6981,7 @@
           <a:noFill/>
           <a:ln w="19050">
             <a:solidFill>
-              <a:srgbClr val="CADCFC"/>
+              <a:srgbClr val="93C5FD"/>
             </a:solidFill>
             <a:prstDash val="solid"/>
           </a:ln>
@@ -7009,7 +7009,7 @@
             <a:avLst/>
           </a:prstGeom>
           <a:solidFill>
-            <a:srgbClr val="0070AD"/>
+            <a:srgbClr val="2563EB"/>
           </a:solidFill>
           <a:ln/>
         </p:spPr>
@@ -7048,7 +7048,7 @@
             <a:r>
               <a:rPr lang="en-US" sz="1000" b="1" dirty="0">
                 <a:solidFill>
-                  <a:srgbClr val="1B365D"/>
+                  <a:srgbClr val="1E3A5F"/>
                 </a:solidFill>
                 <a:latin typeface="Calibri" pitchFamily="34" charset="0"/>
                 <a:ea typeface="Calibri" pitchFamily="34" charset="-122"/>
@@ -7090,7 +7090,7 @@
             <a:r>
               <a:rPr lang="en-US" sz="850" dirty="0">
                 <a:solidFill>
-                  <a:srgbClr val="374151"/>
+                  <a:srgbClr val="334155"/>
                 </a:solidFill>
                 <a:latin typeface="Calibri" pitchFamily="34" charset="0"/>
                 <a:ea typeface="Calibri" pitchFamily="34" charset="-122"/>
@@ -7110,7 +7110,7 @@
             <a:r>
               <a:rPr lang="en-US" sz="850" dirty="0">
                 <a:solidFill>
-                  <a:srgbClr val="374151"/>
+                  <a:srgbClr val="334155"/>
                 </a:solidFill>
                 <a:latin typeface="Calibri" pitchFamily="34" charset="0"/>
                 <a:ea typeface="Calibri" pitchFamily="34" charset="-122"/>
@@ -7171,7 +7171,7 @@
             <a:avLst/>
           </a:prstGeom>
           <a:solidFill>
-            <a:srgbClr val="10B981"/>
+            <a:srgbClr val="14B8A6"/>
           </a:solidFill>
           <a:ln/>
         </p:spPr>
@@ -7210,7 +7210,7 @@
             <a:r>
               <a:rPr lang="en-US" sz="1200" b="1" dirty="0">
                 <a:solidFill>
-                  <a:srgbClr val="1B365D"/>
+                  <a:srgbClr val="1E3A5F"/>
                 </a:solidFill>
                 <a:latin typeface="Calibri" pitchFamily="34" charset="0"/>
                 <a:ea typeface="Calibri" pitchFamily="34" charset="-122"/>
@@ -7237,7 +7237,7 @@
             <a:avLst/>
           </a:prstGeom>
           <a:solidFill>
-            <a:srgbClr val="10B981"/>
+            <a:srgbClr val="14B8A6"/>
           </a:solidFill>
           <a:ln/>
         </p:spPr>
@@ -7276,7 +7276,7 @@
             <a:r>
               <a:rPr lang="en-US" sz="1000" b="1" dirty="0">
                 <a:solidFill>
-                  <a:srgbClr val="1B365D"/>
+                  <a:srgbClr val="1E3A5F"/>
                 </a:solidFill>
                 <a:latin typeface="Calibri" pitchFamily="34" charset="0"/>
                 <a:ea typeface="Calibri" pitchFamily="34" charset="-122"/>
@@ -7318,7 +7318,7 @@
             <a:r>
               <a:rPr lang="en-US" sz="850" dirty="0">
                 <a:solidFill>
-                  <a:srgbClr val="374151"/>
+                  <a:srgbClr val="334155"/>
                 </a:solidFill>
                 <a:latin typeface="Calibri" pitchFamily="34" charset="0"/>
                 <a:ea typeface="Calibri" pitchFamily="34" charset="-122"/>
@@ -7338,7 +7338,7 @@
             <a:r>
               <a:rPr lang="en-US" sz="850" dirty="0">
                 <a:solidFill>
-                  <a:srgbClr val="374151"/>
+                  <a:srgbClr val="334155"/>
                 </a:solidFill>
                 <a:latin typeface="Calibri" pitchFamily="34" charset="0"/>
                 <a:ea typeface="Calibri" pitchFamily="34" charset="-122"/>
@@ -7367,7 +7367,7 @@
           <a:noFill/>
           <a:ln w="19050">
             <a:solidFill>
-              <a:srgbClr val="CADCFC"/>
+              <a:srgbClr val="93C5FD"/>
             </a:solidFill>
             <a:prstDash val="solid"/>
           </a:ln>
@@ -7395,7 +7395,7 @@
             <a:avLst/>
           </a:prstGeom>
           <a:solidFill>
-            <a:srgbClr val="10B981"/>
+            <a:srgbClr val="14B8A6"/>
           </a:solidFill>
           <a:ln/>
         </p:spPr>
@@ -7434,7 +7434,7 @@
             <a:r>
               <a:rPr lang="en-US" sz="1000" b="1" dirty="0">
                 <a:solidFill>
-                  <a:srgbClr val="1B365D"/>
+                  <a:srgbClr val="1E3A5F"/>
                 </a:solidFill>
                 <a:latin typeface="Calibri" pitchFamily="34" charset="0"/>
                 <a:ea typeface="Calibri" pitchFamily="34" charset="-122"/>
@@ -7476,7 +7476,7 @@
             <a:r>
               <a:rPr lang="en-US" sz="850" dirty="0">
                 <a:solidFill>
-                  <a:srgbClr val="374151"/>
+                  <a:srgbClr val="334155"/>
                 </a:solidFill>
                 <a:latin typeface="Calibri" pitchFamily="34" charset="0"/>
                 <a:ea typeface="Calibri" pitchFamily="34" charset="-122"/>
@@ -7496,7 +7496,7 @@
             <a:r>
               <a:rPr lang="en-US" sz="850" dirty="0">
                 <a:solidFill>
-                  <a:srgbClr val="374151"/>
+                  <a:srgbClr val="334155"/>
                 </a:solidFill>
                 <a:latin typeface="Calibri" pitchFamily="34" charset="0"/>
                 <a:ea typeface="Calibri" pitchFamily="34" charset="-122"/>
@@ -7525,7 +7525,7 @@
           <a:noFill/>
           <a:ln w="19050">
             <a:solidFill>
-              <a:srgbClr val="CADCFC"/>
+              <a:srgbClr val="93C5FD"/>
             </a:solidFill>
             <a:prstDash val="solid"/>
           </a:ln>
@@ -7553,7 +7553,7 @@
             <a:avLst/>
           </a:prstGeom>
           <a:solidFill>
-            <a:srgbClr val="10B981"/>
+            <a:srgbClr val="14B8A6"/>
           </a:solidFill>
           <a:ln/>
         </p:spPr>
@@ -7592,7 +7592,7 @@
             <a:r>
               <a:rPr lang="en-US" sz="1000" b="1" dirty="0">
                 <a:solidFill>
-                  <a:srgbClr val="1B365D"/>
+                  <a:srgbClr val="1E3A5F"/>
                 </a:solidFill>
                 <a:latin typeface="Calibri" pitchFamily="34" charset="0"/>
                 <a:ea typeface="Calibri" pitchFamily="34" charset="-122"/>
@@ -7634,7 +7634,7 @@
             <a:r>
               <a:rPr lang="en-US" sz="850" dirty="0">
                 <a:solidFill>
-                  <a:srgbClr val="374151"/>
+                  <a:srgbClr val="334155"/>
                 </a:solidFill>
                 <a:latin typeface="Calibri" pitchFamily="34" charset="0"/>
                 <a:ea typeface="Calibri" pitchFamily="34" charset="-122"/>
@@ -7654,7 +7654,7 @@
             <a:r>
               <a:rPr lang="en-US" sz="850" dirty="0">
                 <a:solidFill>
-                  <a:srgbClr val="374151"/>
+                  <a:srgbClr val="334155"/>
                 </a:solidFill>
                 <a:latin typeface="Calibri" pitchFamily="34" charset="0"/>
                 <a:ea typeface="Calibri" pitchFamily="34" charset="-122"/>
@@ -7683,7 +7683,7 @@
           <a:noFill/>
           <a:ln w="19050">
             <a:solidFill>
-              <a:srgbClr val="CADCFC"/>
+              <a:srgbClr val="93C5FD"/>
             </a:solidFill>
             <a:prstDash val="solid"/>
           </a:ln>
@@ -7711,7 +7711,7 @@
             <a:avLst/>
           </a:prstGeom>
           <a:solidFill>
-            <a:srgbClr val="10B981"/>
+            <a:srgbClr val="14B8A6"/>
           </a:solidFill>
           <a:ln/>
         </p:spPr>
@@ -7750,7 +7750,7 @@
             <a:r>
               <a:rPr lang="en-US" sz="1000" b="1" dirty="0">
                 <a:solidFill>
-                  <a:srgbClr val="1B365D"/>
+                  <a:srgbClr val="1E3A5F"/>
                 </a:solidFill>
                 <a:latin typeface="Calibri" pitchFamily="34" charset="0"/>
                 <a:ea typeface="Calibri" pitchFamily="34" charset="-122"/>
@@ -7792,7 +7792,7 @@
             <a:r>
               <a:rPr lang="en-US" sz="850" dirty="0">
                 <a:solidFill>
-                  <a:srgbClr val="374151"/>
+                  <a:srgbClr val="334155"/>
                 </a:solidFill>
                 <a:latin typeface="Calibri" pitchFamily="34" charset="0"/>
                 <a:ea typeface="Calibri" pitchFamily="34" charset="-122"/>
@@ -7821,7 +7821,7 @@
           <a:noFill/>
           <a:ln w="19050">
             <a:solidFill>
-              <a:srgbClr val="CADCFC"/>
+              <a:srgbClr val="93C5FD"/>
             </a:solidFill>
             <a:prstDash val="solid"/>
           </a:ln>
@@ -7849,7 +7849,7 @@
             <a:avLst/>
           </a:prstGeom>
           <a:solidFill>
-            <a:srgbClr val="10B981"/>
+            <a:srgbClr val="14B8A6"/>
           </a:solidFill>
           <a:ln/>
         </p:spPr>
@@ -7888,7 +7888,7 @@
             <a:r>
               <a:rPr lang="en-US" sz="1000" b="1" dirty="0">
                 <a:solidFill>
-                  <a:srgbClr val="1B365D"/>
+                  <a:srgbClr val="1E3A5F"/>
                 </a:solidFill>
                 <a:latin typeface="Calibri" pitchFamily="34" charset="0"/>
                 <a:ea typeface="Calibri" pitchFamily="34" charset="-122"/>
@@ -7930,7 +7930,7 @@
             <a:r>
               <a:rPr lang="en-US" sz="850" dirty="0">
                 <a:solidFill>
-                  <a:srgbClr val="374151"/>
+                  <a:srgbClr val="334155"/>
                 </a:solidFill>
                 <a:latin typeface="Calibri" pitchFamily="34" charset="0"/>
                 <a:ea typeface="Calibri" pitchFamily="34" charset="-122"/>
@@ -7950,7 +7950,7 @@
             <a:r>
               <a:rPr lang="en-US" sz="850" dirty="0">
                 <a:solidFill>
-                  <a:srgbClr val="374151"/>
+                  <a:srgbClr val="334155"/>
                 </a:solidFill>
                 <a:latin typeface="Calibri" pitchFamily="34" charset="0"/>
                 <a:ea typeface="Calibri" pitchFamily="34" charset="-122"/>
@@ -7979,7 +7979,7 @@
           <a:noFill/>
           <a:ln w="19050">
             <a:solidFill>
-              <a:srgbClr val="CADCFC"/>
+              <a:srgbClr val="93C5FD"/>
             </a:solidFill>
             <a:prstDash val="solid"/>
           </a:ln>
@@ -8007,7 +8007,7 @@
             <a:avLst/>
           </a:prstGeom>
           <a:solidFill>
-            <a:srgbClr val="10B981"/>
+            <a:srgbClr val="14B8A6"/>
           </a:solidFill>
           <a:ln/>
         </p:spPr>
@@ -8046,7 +8046,7 @@
             <a:r>
               <a:rPr lang="en-US" sz="1000" b="1" dirty="0">
                 <a:solidFill>
-                  <a:srgbClr val="1B365D"/>
+                  <a:srgbClr val="1E3A5F"/>
                 </a:solidFill>
                 <a:latin typeface="Calibri" pitchFamily="34" charset="0"/>
                 <a:ea typeface="Calibri" pitchFamily="34" charset="-122"/>
@@ -8088,7 +8088,7 @@
             <a:r>
               <a:rPr lang="en-US" sz="850" dirty="0">
                 <a:solidFill>
-                  <a:srgbClr val="374151"/>
+                  <a:srgbClr val="334155"/>
                 </a:solidFill>
                 <a:latin typeface="Calibri" pitchFamily="34" charset="0"/>
                 <a:ea typeface="Calibri" pitchFamily="34" charset="-122"/>
@@ -8108,7 +8108,7 @@
             <a:r>
               <a:rPr lang="en-US" sz="850" dirty="0">
                 <a:solidFill>
-                  <a:srgbClr val="374151"/>
+                  <a:srgbClr val="334155"/>
                 </a:solidFill>
                 <a:latin typeface="Calibri" pitchFamily="34" charset="0"/>
                 <a:ea typeface="Calibri" pitchFamily="34" charset="-122"/>
@@ -8175,7 +8175,7 @@
             <a:r>
               <a:rPr lang="en-US" sz="900" dirty="0">
                 <a:solidFill>
-                  <a:srgbClr val="6B7280"/>
+                  <a:srgbClr val="64748B"/>
                 </a:solidFill>
                 <a:latin typeface="Calibri" pitchFamily="34" charset="0"/>
                 <a:ea typeface="Calibri" pitchFamily="34" charset="-122"/>
@@ -8506,13 +8506,13 @@
         <a:sysClr val="window" lastClr="FFFFFF"/>
       </a:lt1>
       <a:dk2>
-        <a:srgbClr val="44546A"/>
+        <a:srgbClr val="475569"/>
       </a:dk2>
       <a:lt2>
         <a:srgbClr val="E7E6E6"/>
       </a:lt2>
       <a:accent1>
-        <a:srgbClr val="4472C4"/>
+        <a:srgbClr val="2563EB"/>
       </a:accent1>
       <a:accent2>
         <a:srgbClr val="ED7D31"/>
@@ -8524,13 +8524,13 @@
         <a:srgbClr val="FFC000"/>
       </a:accent4>
       <a:accent5>
-        <a:srgbClr val="5B9BD5"/>
+        <a:srgbClr val="3B82F6"/>
       </a:accent5>
       <a:accent6>
         <a:srgbClr val="70AD47"/>
       </a:accent6>
       <a:hlink>
-        <a:srgbClr val="0563C1"/>
+        <a:srgbClr val="2563EB"/>
       </a:hlink>
       <a:folHlink>
         <a:srgbClr val="954F72"/>

</xml_diff>

<commit_message>
Add step headings to all screenshot slides
Slides 5-13 now have dark navy headers with:
- Step number and title (white, bold)
- Subtitle description (sky blue)
- Blue accent bar at top
- Screenshots repositioned below heading

Co-Authored-By: Claude Opus 4.6 <noreply@anthropic.com>
</commit_message>
<xml_diff>
--- a/MuleSoft-to-SpringBoot-Migrator-Technical-Presentation.pptx
+++ b/MuleSoft-to-SpringBoot-Migrator-Technical-Presentation.pptx
@@ -1715,14 +1715,148 @@
         </p:blipFill>
         <p:spPr>
           <a:xfrm>
-            <a:off x="0" y="382950"/>
-            <a:ext cx="9144000" cy="4377600"/>
+            <a:off x="274320" y="868680"/>
+            <a:ext cx="8595360" cy="4096512"/>
           </a:xfrm>
           <a:prstGeom prst="rect">
             <a:avLst/>
           </a:prstGeom>
         </p:spPr>
       </p:pic>
+      <p:sp>
+        <p:nvSpPr>
+          <p:cNvPr id="100" name="BgRect"/>
+          <p:cNvSpPr/>
+          <p:nvPr/>
+        </p:nvSpPr>
+        <p:spPr>
+          <a:xfrm>
+            <a:off x="0" y="0"/>
+            <a:ext cx="9144000" cy="5143500"/>
+          </a:xfrm>
+          <a:prstGeom prst="rect">
+            <a:avLst/>
+          </a:prstGeom>
+          <a:solidFill>
+            <a:srgbClr val="0B1A33"/>
+          </a:solidFill>
+          <a:ln>
+            <a:noFill/>
+          </a:ln>
+        </p:spPr>
+        <p:txBody>
+          <a:bodyPr/>
+          <a:lstStyle/>
+          <a:p>
+            <a:endParaRPr lang="en-US"/>
+          </a:p>
+        </p:txBody>
+      </p:sp>
+      <p:sp>
+        <p:nvSpPr>
+          <p:cNvPr id="101" name="AccentBar"/>
+          <p:cNvSpPr/>
+          <p:nvPr/>
+        </p:nvSpPr>
+        <p:spPr>
+          <a:xfrm>
+            <a:off x="0" y="0"/>
+            <a:ext cx="9144000" cy="54864"/>
+          </a:xfrm>
+          <a:prstGeom prst="rect">
+            <a:avLst/>
+          </a:prstGeom>
+          <a:solidFill>
+            <a:srgbClr val="2563EB"/>
+          </a:solidFill>
+          <a:ln>
+            <a:noFill/>
+          </a:ln>
+        </p:spPr>
+        <p:txBody>
+          <a:bodyPr/>
+          <a:lstStyle/>
+          <a:p>
+            <a:endParaRPr lang="en-US"/>
+          </a:p>
+        </p:txBody>
+      </p:sp>
+      <p:sp>
+        <p:nvSpPr>
+          <p:cNvPr id="102" name="Title"/>
+          <p:cNvSpPr/>
+          <p:nvPr/>
+        </p:nvSpPr>
+        <p:spPr>
+          <a:xfrm>
+            <a:off x="457200" y="137160"/>
+            <a:ext cx="8229600" cy="365760"/>
+          </a:xfrm>
+          <a:prstGeom prst="rect">
+            <a:avLst/>
+          </a:prstGeom>
+          <a:noFill/>
+          <a:ln>
+            <a:noFill/>
+          </a:ln>
+        </p:spPr>
+        <p:txBody>
+          <a:bodyPr wrap="square" lIns="0" tIns="0" rIns="0" bIns="0" rtlCol="0" anchor="b"/>
+          <a:lstStyle/>
+          <a:p>
+            <a:pPr marL="0" indent="0">
+              <a:buNone/>
+            </a:pPr>
+            <a:r>
+              <a:rPr lang="en-US" sz="2000" b="1" dirty="0">
+                <a:solidFill>
+                  <a:srgbClr val="FFFFFF"/>
+                </a:solidFill>
+                <a:latin typeface="Calibri" pitchFamily="34" charset="0"/>
+              </a:rPr>
+              <a:t>Step 6: RAG Knowledge Base</a:t>
+            </a:r>
+          </a:p>
+        </p:txBody>
+      </p:sp>
+      <p:sp>
+        <p:nvSpPr>
+          <p:cNvPr id="103" name="Subtitle"/>
+          <p:cNvSpPr/>
+          <p:nvPr/>
+        </p:nvSpPr>
+        <p:spPr>
+          <a:xfrm>
+            <a:off x="457200" y="502920"/>
+            <a:ext cx="8229600" cy="274320"/>
+          </a:xfrm>
+          <a:prstGeom prst="rect">
+            <a:avLst/>
+          </a:prstGeom>
+          <a:noFill/>
+          <a:ln>
+            <a:noFill/>
+          </a:ln>
+        </p:spPr>
+        <p:txBody>
+          <a:bodyPr wrap="square" lIns="0" tIns="0" rIns="0" bIns="0" rtlCol="0" anchor="t"/>
+          <a:lstStyle/>
+          <a:p>
+            <a:pPr marL="0" indent="0">
+              <a:buNone/>
+            </a:pPr>
+            <a:r>
+              <a:rPr lang="en-US" sz="1100" dirty="0">
+                <a:solidFill>
+                  <a:srgbClr val="93C5FD"/>
+                </a:solidFill>
+                <a:latin typeface="Calibri" pitchFamily="34" charset="0"/>
+              </a:rPr>
+              <a:t>265 documents, 2650 embeddings powering AI migration agents</a:t>
+            </a:r>
+          </a:p>
+        </p:txBody>
+      </p:sp>
     </p:spTree>
     <p:extLst>
       <p:ext uri="{BB962C8B-B14F-4D97-AF65-F5344CB8AC3E}">
@@ -1775,14 +1909,148 @@
         </p:blipFill>
         <p:spPr>
           <a:xfrm>
-            <a:off x="0" y="372652"/>
-            <a:ext cx="9144000" cy="4398196"/>
+            <a:off x="274320" y="868680"/>
+            <a:ext cx="8595360" cy="4096512"/>
           </a:xfrm>
           <a:prstGeom prst="rect">
             <a:avLst/>
           </a:prstGeom>
         </p:spPr>
       </p:pic>
+      <p:sp>
+        <p:nvSpPr>
+          <p:cNvPr id="100" name="BgRect"/>
+          <p:cNvSpPr/>
+          <p:nvPr/>
+        </p:nvSpPr>
+        <p:spPr>
+          <a:xfrm>
+            <a:off x="0" y="0"/>
+            <a:ext cx="9144000" cy="5143500"/>
+          </a:xfrm>
+          <a:prstGeom prst="rect">
+            <a:avLst/>
+          </a:prstGeom>
+          <a:solidFill>
+            <a:srgbClr val="0B1A33"/>
+          </a:solidFill>
+          <a:ln>
+            <a:noFill/>
+          </a:ln>
+        </p:spPr>
+        <p:txBody>
+          <a:bodyPr/>
+          <a:lstStyle/>
+          <a:p>
+            <a:endParaRPr lang="en-US"/>
+          </a:p>
+        </p:txBody>
+      </p:sp>
+      <p:sp>
+        <p:nvSpPr>
+          <p:cNvPr id="101" name="AccentBar"/>
+          <p:cNvSpPr/>
+          <p:nvPr/>
+        </p:nvSpPr>
+        <p:spPr>
+          <a:xfrm>
+            <a:off x="0" y="0"/>
+            <a:ext cx="9144000" cy="54864"/>
+          </a:xfrm>
+          <a:prstGeom prst="rect">
+            <a:avLst/>
+          </a:prstGeom>
+          <a:solidFill>
+            <a:srgbClr val="2563EB"/>
+          </a:solidFill>
+          <a:ln>
+            <a:noFill/>
+          </a:ln>
+        </p:spPr>
+        <p:txBody>
+          <a:bodyPr/>
+          <a:lstStyle/>
+          <a:p>
+            <a:endParaRPr lang="en-US"/>
+          </a:p>
+        </p:txBody>
+      </p:sp>
+      <p:sp>
+        <p:nvSpPr>
+          <p:cNvPr id="102" name="Title"/>
+          <p:cNvSpPr/>
+          <p:nvPr/>
+        </p:nvSpPr>
+        <p:spPr>
+          <a:xfrm>
+            <a:off x="457200" y="137160"/>
+            <a:ext cx="8229600" cy="365760"/>
+          </a:xfrm>
+          <a:prstGeom prst="rect">
+            <a:avLst/>
+          </a:prstGeom>
+          <a:noFill/>
+          <a:ln>
+            <a:noFill/>
+          </a:ln>
+        </p:spPr>
+        <p:txBody>
+          <a:bodyPr wrap="square" lIns="0" tIns="0" rIns="0" bIns="0" rtlCol="0" anchor="b"/>
+          <a:lstStyle/>
+          <a:p>
+            <a:pPr marL="0" indent="0">
+              <a:buNone/>
+            </a:pPr>
+            <a:r>
+              <a:rPr lang="en-US" sz="2000" b="1" dirty="0">
+                <a:solidFill>
+                  <a:srgbClr val="FFFFFF"/>
+                </a:solidFill>
+                <a:latin typeface="Calibri" pitchFamily="34" charset="0"/>
+              </a:rPr>
+              <a:t>Step 7: Validation Config</a:t>
+            </a:r>
+          </a:p>
+        </p:txBody>
+      </p:sp>
+      <p:sp>
+        <p:nvSpPr>
+          <p:cNvPr id="103" name="Subtitle"/>
+          <p:cNvSpPr/>
+          <p:nvPr/>
+        </p:nvSpPr>
+        <p:spPr>
+          <a:xfrm>
+            <a:off x="457200" y="502920"/>
+            <a:ext cx="8229600" cy="274320"/>
+          </a:xfrm>
+          <a:prstGeom prst="rect">
+            <a:avLst/>
+          </a:prstGeom>
+          <a:noFill/>
+          <a:ln>
+            <a:noFill/>
+          </a:ln>
+        </p:spPr>
+        <p:txBody>
+          <a:bodyPr wrap="square" lIns="0" tIns="0" rIns="0" bIns="0" rtlCol="0" anchor="t"/>
+          <a:lstStyle/>
+          <a:p>
+            <a:pPr marL="0" indent="0">
+              <a:buNone/>
+            </a:pPr>
+            <a:r>
+              <a:rPr lang="en-US" sz="1100" dirty="0">
+                <a:solidFill>
+                  <a:srgbClr val="93C5FD"/>
+                </a:solidFill>
+                <a:latin typeface="Calibri" pitchFamily="34" charset="0"/>
+              </a:rPr>
+              <a:t>Deployment settings, testing mode, MuleSoft base URL  &amp; endpoint list</a:t>
+            </a:r>
+          </a:p>
+        </p:txBody>
+      </p:sp>
     </p:spTree>
     <p:extLst>
       <p:ext uri="{BB962C8B-B14F-4D97-AF65-F5344CB8AC3E}">
@@ -1835,14 +2103,148 @@
         </p:blipFill>
         <p:spPr>
           <a:xfrm>
-            <a:off x="0" y="382950"/>
-            <a:ext cx="9144000" cy="4377600"/>
+            <a:off x="274320" y="868680"/>
+            <a:ext cx="8595360" cy="4096512"/>
           </a:xfrm>
           <a:prstGeom prst="rect">
             <a:avLst/>
           </a:prstGeom>
         </p:spPr>
       </p:pic>
+      <p:sp>
+        <p:nvSpPr>
+          <p:cNvPr id="100" name="BgRect"/>
+          <p:cNvSpPr/>
+          <p:nvPr/>
+        </p:nvSpPr>
+        <p:spPr>
+          <a:xfrm>
+            <a:off x="0" y="0"/>
+            <a:ext cx="9144000" cy="5143500"/>
+          </a:xfrm>
+          <a:prstGeom prst="rect">
+            <a:avLst/>
+          </a:prstGeom>
+          <a:solidFill>
+            <a:srgbClr val="0B1A33"/>
+          </a:solidFill>
+          <a:ln>
+            <a:noFill/>
+          </a:ln>
+        </p:spPr>
+        <p:txBody>
+          <a:bodyPr/>
+          <a:lstStyle/>
+          <a:p>
+            <a:endParaRPr lang="en-US"/>
+          </a:p>
+        </p:txBody>
+      </p:sp>
+      <p:sp>
+        <p:nvSpPr>
+          <p:cNvPr id="101" name="AccentBar"/>
+          <p:cNvSpPr/>
+          <p:nvPr/>
+        </p:nvSpPr>
+        <p:spPr>
+          <a:xfrm>
+            <a:off x="0" y="0"/>
+            <a:ext cx="9144000" cy="54864"/>
+          </a:xfrm>
+          <a:prstGeom prst="rect">
+            <a:avLst/>
+          </a:prstGeom>
+          <a:solidFill>
+            <a:srgbClr val="2563EB"/>
+          </a:solidFill>
+          <a:ln>
+            <a:noFill/>
+          </a:ln>
+        </p:spPr>
+        <p:txBody>
+          <a:bodyPr/>
+          <a:lstStyle/>
+          <a:p>
+            <a:endParaRPr lang="en-US"/>
+          </a:p>
+        </p:txBody>
+      </p:sp>
+      <p:sp>
+        <p:nvSpPr>
+          <p:cNvPr id="102" name="Title"/>
+          <p:cNvSpPr/>
+          <p:nvPr/>
+        </p:nvSpPr>
+        <p:spPr>
+          <a:xfrm>
+            <a:off x="457200" y="137160"/>
+            <a:ext cx="8229600" cy="365760"/>
+          </a:xfrm>
+          <a:prstGeom prst="rect">
+            <a:avLst/>
+          </a:prstGeom>
+          <a:noFill/>
+          <a:ln>
+            <a:noFill/>
+          </a:ln>
+        </p:spPr>
+        <p:txBody>
+          <a:bodyPr wrap="square" lIns="0" tIns="0" rIns="0" bIns="0" rtlCol="0" anchor="b"/>
+          <a:lstStyle/>
+          <a:p>
+            <a:pPr marL="0" indent="0">
+              <a:buNone/>
+            </a:pPr>
+            <a:r>
+              <a:rPr lang="en-US" sz="2000" b="1" dirty="0">
+                <a:solidFill>
+                  <a:srgbClr val="FFFFFF"/>
+                </a:solidFill>
+                <a:latin typeface="Calibri" pitchFamily="34" charset="0"/>
+              </a:rPr>
+              <a:t>Step 8: Validation Running</a:t>
+            </a:r>
+          </a:p>
+        </p:txBody>
+      </p:sp>
+      <p:sp>
+        <p:nvSpPr>
+          <p:cNvPr id="103" name="Subtitle"/>
+          <p:cNvSpPr/>
+          <p:nvPr/>
+        </p:nvSpPr>
+        <p:spPr>
+          <a:xfrm>
+            <a:off x="457200" y="502920"/>
+            <a:ext cx="8229600" cy="274320"/>
+          </a:xfrm>
+          <a:prstGeom prst="rect">
+            <a:avLst/>
+          </a:prstGeom>
+          <a:noFill/>
+          <a:ln>
+            <a:noFill/>
+          </a:ln>
+        </p:spPr>
+        <p:txBody>
+          <a:bodyPr wrap="square" lIns="0" tIns="0" rIns="0" bIns="0" rtlCol="0" anchor="t"/>
+          <a:lstStyle/>
+          <a:p>
+            <a:pPr marL="0" indent="0">
+              <a:buNone/>
+            </a:pPr>
+            <a:r>
+              <a:rPr lang="en-US" sz="1100" dirty="0">
+                <a:solidFill>
+                  <a:srgbClr val="93C5FD"/>
+                </a:solidFill>
+                <a:latin typeface="Calibri" pitchFamily="34" charset="0"/>
+              </a:rPr>
+              <a:t>Docker build, ACI deploy, health check  &amp; container logs</a:t>
+            </a:r>
+          </a:p>
+        </p:txBody>
+      </p:sp>
     </p:spTree>
     <p:extLst>
       <p:ext uri="{BB962C8B-B14F-4D97-AF65-F5344CB8AC3E}">
@@ -1895,14 +2297,148 @@
         </p:blipFill>
         <p:spPr>
           <a:xfrm>
-            <a:off x="0" y="386391"/>
-            <a:ext cx="9144000" cy="4370717"/>
+            <a:off x="274320" y="868680"/>
+            <a:ext cx="8595360" cy="4096512"/>
           </a:xfrm>
           <a:prstGeom prst="rect">
             <a:avLst/>
           </a:prstGeom>
         </p:spPr>
       </p:pic>
+      <p:sp>
+        <p:nvSpPr>
+          <p:cNvPr id="100" name="BgRect"/>
+          <p:cNvSpPr/>
+          <p:nvPr/>
+        </p:nvSpPr>
+        <p:spPr>
+          <a:xfrm>
+            <a:off x="0" y="0"/>
+            <a:ext cx="9144000" cy="5143500"/>
+          </a:xfrm>
+          <a:prstGeom prst="rect">
+            <a:avLst/>
+          </a:prstGeom>
+          <a:solidFill>
+            <a:srgbClr val="0B1A33"/>
+          </a:solidFill>
+          <a:ln>
+            <a:noFill/>
+          </a:ln>
+        </p:spPr>
+        <p:txBody>
+          <a:bodyPr/>
+          <a:lstStyle/>
+          <a:p>
+            <a:endParaRPr lang="en-US"/>
+          </a:p>
+        </p:txBody>
+      </p:sp>
+      <p:sp>
+        <p:nvSpPr>
+          <p:cNvPr id="101" name="AccentBar"/>
+          <p:cNvSpPr/>
+          <p:nvPr/>
+        </p:nvSpPr>
+        <p:spPr>
+          <a:xfrm>
+            <a:off x="0" y="0"/>
+            <a:ext cx="9144000" cy="54864"/>
+          </a:xfrm>
+          <a:prstGeom prst="rect">
+            <a:avLst/>
+          </a:prstGeom>
+          <a:solidFill>
+            <a:srgbClr val="2563EB"/>
+          </a:solidFill>
+          <a:ln>
+            <a:noFill/>
+          </a:ln>
+        </p:spPr>
+        <p:txBody>
+          <a:bodyPr/>
+          <a:lstStyle/>
+          <a:p>
+            <a:endParaRPr lang="en-US"/>
+          </a:p>
+        </p:txBody>
+      </p:sp>
+      <p:sp>
+        <p:nvSpPr>
+          <p:cNvPr id="102" name="Title"/>
+          <p:cNvSpPr/>
+          <p:nvPr/>
+        </p:nvSpPr>
+        <p:spPr>
+          <a:xfrm>
+            <a:off x="457200" y="137160"/>
+            <a:ext cx="8229600" cy="365760"/>
+          </a:xfrm>
+          <a:prstGeom prst="rect">
+            <a:avLst/>
+          </a:prstGeom>
+          <a:noFill/>
+          <a:ln>
+            <a:noFill/>
+          </a:ln>
+        </p:spPr>
+        <p:txBody>
+          <a:bodyPr wrap="square" lIns="0" tIns="0" rIns="0" bIns="0" rtlCol="0" anchor="b"/>
+          <a:lstStyle/>
+          <a:p>
+            <a:pPr marL="0" indent="0">
+              <a:buNone/>
+            </a:pPr>
+            <a:r>
+              <a:rPr lang="en-US" sz="2000" b="1" dirty="0">
+                <a:solidFill>
+                  <a:srgbClr val="FFFFFF"/>
+                </a:solidFill>
+                <a:latin typeface="Calibri" pitchFamily="34" charset="0"/>
+              </a:rPr>
+              <a:t>Step 9: API Comparison</a:t>
+            </a:r>
+          </a:p>
+        </p:txBody>
+      </p:sp>
+      <p:sp>
+        <p:nvSpPr>
+          <p:cNvPr id="103" name="Subtitle"/>
+          <p:cNvSpPr/>
+          <p:nvPr/>
+        </p:nvSpPr>
+        <p:spPr>
+          <a:xfrm>
+            <a:off x="457200" y="502920"/>
+            <a:ext cx="8229600" cy="274320"/>
+          </a:xfrm>
+          <a:prstGeom prst="rect">
+            <a:avLst/>
+          </a:prstGeom>
+          <a:noFill/>
+          <a:ln>
+            <a:noFill/>
+          </a:ln>
+        </p:spPr>
+        <p:txBody>
+          <a:bodyPr wrap="square" lIns="0" tIns="0" rIns="0" bIns="0" rtlCol="0" anchor="t"/>
+          <a:lstStyle/>
+          <a:p>
+            <a:pPr marL="0" indent="0">
+              <a:buNone/>
+            </a:pPr>
+            <a:r>
+              <a:rPr lang="en-US" sz="1100" dirty="0">
+                <a:solidFill>
+                  <a:srgbClr val="93C5FD"/>
+                </a:solidFill>
+                <a:latin typeface="Calibri" pitchFamily="34" charset="0"/>
+              </a:rPr>
+              <a:t>9/9 endpoints matched — MuleSoft vs Spring Boot side-by-side</a:t>
+            </a:r>
+          </a:p>
+        </p:txBody>
+      </p:sp>
     </p:spTree>
     <p:extLst>
       <p:ext uri="{BB962C8B-B14F-4D97-AF65-F5344CB8AC3E}">
@@ -8234,14 +8770,148 @@
         </p:blipFill>
         <p:spPr>
           <a:xfrm>
-            <a:off x="629062" y="887914"/>
-            <a:ext cx="7056251" cy="3367672"/>
+            <a:off x="274320" y="868680"/>
+            <a:ext cx="8595360" cy="4096512"/>
           </a:xfrm>
           <a:prstGeom prst="rect">
             <a:avLst/>
           </a:prstGeom>
         </p:spPr>
       </p:pic>
+      <p:sp>
+        <p:nvSpPr>
+          <p:cNvPr id="100" name="BgRect"/>
+          <p:cNvSpPr/>
+          <p:nvPr/>
+        </p:nvSpPr>
+        <p:spPr>
+          <a:xfrm>
+            <a:off x="0" y="0"/>
+            <a:ext cx="9144000" cy="5143500"/>
+          </a:xfrm>
+          <a:prstGeom prst="rect">
+            <a:avLst/>
+          </a:prstGeom>
+          <a:solidFill>
+            <a:srgbClr val="0B1A33"/>
+          </a:solidFill>
+          <a:ln>
+            <a:noFill/>
+          </a:ln>
+        </p:spPr>
+        <p:txBody>
+          <a:bodyPr/>
+          <a:lstStyle/>
+          <a:p>
+            <a:endParaRPr lang="en-US"/>
+          </a:p>
+        </p:txBody>
+      </p:sp>
+      <p:sp>
+        <p:nvSpPr>
+          <p:cNvPr id="101" name="AccentBar"/>
+          <p:cNvSpPr/>
+          <p:nvPr/>
+        </p:nvSpPr>
+        <p:spPr>
+          <a:xfrm>
+            <a:off x="0" y="0"/>
+            <a:ext cx="9144000" cy="54864"/>
+          </a:xfrm>
+          <a:prstGeom prst="rect">
+            <a:avLst/>
+          </a:prstGeom>
+          <a:solidFill>
+            <a:srgbClr val="2563EB"/>
+          </a:solidFill>
+          <a:ln>
+            <a:noFill/>
+          </a:ln>
+        </p:spPr>
+        <p:txBody>
+          <a:bodyPr/>
+          <a:lstStyle/>
+          <a:p>
+            <a:endParaRPr lang="en-US"/>
+          </a:p>
+        </p:txBody>
+      </p:sp>
+      <p:sp>
+        <p:nvSpPr>
+          <p:cNvPr id="102" name="Title"/>
+          <p:cNvSpPr/>
+          <p:nvPr/>
+        </p:nvSpPr>
+        <p:spPr>
+          <a:xfrm>
+            <a:off x="457200" y="137160"/>
+            <a:ext cx="8229600" cy="365760"/>
+          </a:xfrm>
+          <a:prstGeom prst="rect">
+            <a:avLst/>
+          </a:prstGeom>
+          <a:noFill/>
+          <a:ln>
+            <a:noFill/>
+          </a:ln>
+        </p:spPr>
+        <p:txBody>
+          <a:bodyPr wrap="square" lIns="0" tIns="0" rIns="0" bIns="0" rtlCol="0" anchor="b"/>
+          <a:lstStyle/>
+          <a:p>
+            <a:pPr marL="0" indent="0">
+              <a:buNone/>
+            </a:pPr>
+            <a:r>
+              <a:rPr lang="en-US" sz="2000" b="1" dirty="0">
+                <a:solidFill>
+                  <a:srgbClr val="FFFFFF"/>
+                </a:solidFill>
+                <a:latin typeface="Calibri" pitchFamily="34" charset="0"/>
+              </a:rPr>
+              <a:t>Step 1: Dashboard</a:t>
+            </a:r>
+          </a:p>
+        </p:txBody>
+      </p:sp>
+      <p:sp>
+        <p:nvSpPr>
+          <p:cNvPr id="103" name="Subtitle"/>
+          <p:cNvSpPr/>
+          <p:nvPr/>
+        </p:nvSpPr>
+        <p:spPr>
+          <a:xfrm>
+            <a:off x="457200" y="502920"/>
+            <a:ext cx="8229600" cy="274320"/>
+          </a:xfrm>
+          <a:prstGeom prst="rect">
+            <a:avLst/>
+          </a:prstGeom>
+          <a:noFill/>
+          <a:ln>
+            <a:noFill/>
+          </a:ln>
+        </p:spPr>
+        <p:txBody>
+          <a:bodyPr wrap="square" lIns="0" tIns="0" rIns="0" bIns="0" rtlCol="0" anchor="t"/>
+          <a:lstStyle/>
+          <a:p>
+            <a:pPr marL="0" indent="0">
+              <a:buNone/>
+            </a:pPr>
+            <a:r>
+              <a:rPr lang="en-US" sz="1100" dirty="0">
+                <a:solidFill>
+                  <a:srgbClr val="93C5FD"/>
+                </a:solidFill>
+                <a:latin typeface="Calibri" pitchFamily="34" charset="0"/>
+              </a:rPr>
+              <a:t>Migration overview, stats, recent activity  &amp; weekly trends</a:t>
+            </a:r>
+          </a:p>
+        </p:txBody>
+      </p:sp>
     </p:spTree>
     <p:extLst>
       <p:ext uri="{BB962C8B-B14F-4D97-AF65-F5344CB8AC3E}">
@@ -8294,14 +8964,148 @@
         </p:blipFill>
         <p:spPr>
           <a:xfrm>
-            <a:off x="0" y="357453"/>
-            <a:ext cx="9144000" cy="4428593"/>
+            <a:off x="274320" y="868680"/>
+            <a:ext cx="8595360" cy="4096512"/>
           </a:xfrm>
           <a:prstGeom prst="rect">
             <a:avLst/>
           </a:prstGeom>
         </p:spPr>
       </p:pic>
+      <p:sp>
+        <p:nvSpPr>
+          <p:cNvPr id="100" name="BgRect"/>
+          <p:cNvSpPr/>
+          <p:nvPr/>
+        </p:nvSpPr>
+        <p:spPr>
+          <a:xfrm>
+            <a:off x="0" y="0"/>
+            <a:ext cx="9144000" cy="5143500"/>
+          </a:xfrm>
+          <a:prstGeom prst="rect">
+            <a:avLst/>
+          </a:prstGeom>
+          <a:solidFill>
+            <a:srgbClr val="0B1A33"/>
+          </a:solidFill>
+          <a:ln>
+            <a:noFill/>
+          </a:ln>
+        </p:spPr>
+        <p:txBody>
+          <a:bodyPr/>
+          <a:lstStyle/>
+          <a:p>
+            <a:endParaRPr lang="en-US"/>
+          </a:p>
+        </p:txBody>
+      </p:sp>
+      <p:sp>
+        <p:nvSpPr>
+          <p:cNvPr id="101" name="AccentBar"/>
+          <p:cNvSpPr/>
+          <p:nvPr/>
+        </p:nvSpPr>
+        <p:spPr>
+          <a:xfrm>
+            <a:off x="0" y="0"/>
+            <a:ext cx="9144000" cy="54864"/>
+          </a:xfrm>
+          <a:prstGeom prst="rect">
+            <a:avLst/>
+          </a:prstGeom>
+          <a:solidFill>
+            <a:srgbClr val="2563EB"/>
+          </a:solidFill>
+          <a:ln>
+            <a:noFill/>
+          </a:ln>
+        </p:spPr>
+        <p:txBody>
+          <a:bodyPr/>
+          <a:lstStyle/>
+          <a:p>
+            <a:endParaRPr lang="en-US"/>
+          </a:p>
+        </p:txBody>
+      </p:sp>
+      <p:sp>
+        <p:nvSpPr>
+          <p:cNvPr id="102" name="Title"/>
+          <p:cNvSpPr/>
+          <p:nvPr/>
+        </p:nvSpPr>
+        <p:spPr>
+          <a:xfrm>
+            <a:off x="457200" y="137160"/>
+            <a:ext cx="8229600" cy="365760"/>
+          </a:xfrm>
+          <a:prstGeom prst="rect">
+            <a:avLst/>
+          </a:prstGeom>
+          <a:noFill/>
+          <a:ln>
+            <a:noFill/>
+          </a:ln>
+        </p:spPr>
+        <p:txBody>
+          <a:bodyPr wrap="square" lIns="0" tIns="0" rIns="0" bIns="0" rtlCol="0" anchor="b"/>
+          <a:lstStyle/>
+          <a:p>
+            <a:pPr marL="0" indent="0">
+              <a:buNone/>
+            </a:pPr>
+            <a:r>
+              <a:rPr lang="en-US" sz="2000" b="1" dirty="0">
+                <a:solidFill>
+                  <a:srgbClr val="FFFFFF"/>
+                </a:solidFill>
+                <a:latin typeface="Calibri" pitchFamily="34" charset="0"/>
+              </a:rPr>
+              <a:t>Step 2: Upload  &amp; Configure</a:t>
+            </a:r>
+          </a:p>
+        </p:txBody>
+      </p:sp>
+      <p:sp>
+        <p:nvSpPr>
+          <p:cNvPr id="103" name="Subtitle"/>
+          <p:cNvSpPr/>
+          <p:nvPr/>
+        </p:nvSpPr>
+        <p:spPr>
+          <a:xfrm>
+            <a:off x="457200" y="502920"/>
+            <a:ext cx="8229600" cy="274320"/>
+          </a:xfrm>
+          <a:prstGeom prst="rect">
+            <a:avLst/>
+          </a:prstGeom>
+          <a:noFill/>
+          <a:ln>
+            <a:noFill/>
+          </a:ln>
+        </p:spPr>
+        <p:txBody>
+          <a:bodyPr wrap="square" lIns="0" tIns="0" rIns="0" bIns="0" rtlCol="0" anchor="t"/>
+          <a:lstStyle/>
+          <a:p>
+            <a:pPr marL="0" indent="0">
+              <a:buNone/>
+            </a:pPr>
+            <a:r>
+              <a:rPr lang="en-US" sz="1100" dirty="0">
+                <a:solidFill>
+                  <a:srgbClr val="93C5FD"/>
+                </a:solidFill>
+                <a:latin typeface="Calibri" pitchFamily="34" charset="0"/>
+              </a:rPr>
+              <a:t>Drag  &amp; drop MuleSoft project, set migration options, enable AI enhancement</a:t>
+            </a:r>
+          </a:p>
+        </p:txBody>
+      </p:sp>
     </p:spTree>
     <p:extLst>
       <p:ext uri="{BB962C8B-B14F-4D97-AF65-F5344CB8AC3E}">
@@ -8354,14 +9158,148 @@
         </p:blipFill>
         <p:spPr>
           <a:xfrm>
-            <a:off x="0" y="379596"/>
-            <a:ext cx="9144000" cy="4384307"/>
+            <a:off x="274320" y="868680"/>
+            <a:ext cx="8595360" cy="4096512"/>
           </a:xfrm>
           <a:prstGeom prst="rect">
             <a:avLst/>
           </a:prstGeom>
         </p:spPr>
       </p:pic>
+      <p:sp>
+        <p:nvSpPr>
+          <p:cNvPr id="100" name="BgRect"/>
+          <p:cNvSpPr/>
+          <p:nvPr/>
+        </p:nvSpPr>
+        <p:spPr>
+          <a:xfrm>
+            <a:off x="0" y="0"/>
+            <a:ext cx="9144000" cy="5143500"/>
+          </a:xfrm>
+          <a:prstGeom prst="rect">
+            <a:avLst/>
+          </a:prstGeom>
+          <a:solidFill>
+            <a:srgbClr val="0B1A33"/>
+          </a:solidFill>
+          <a:ln>
+            <a:noFill/>
+          </a:ln>
+        </p:spPr>
+        <p:txBody>
+          <a:bodyPr/>
+          <a:lstStyle/>
+          <a:p>
+            <a:endParaRPr lang="en-US"/>
+          </a:p>
+        </p:txBody>
+      </p:sp>
+      <p:sp>
+        <p:nvSpPr>
+          <p:cNvPr id="101" name="AccentBar"/>
+          <p:cNvSpPr/>
+          <p:nvPr/>
+        </p:nvSpPr>
+        <p:spPr>
+          <a:xfrm>
+            <a:off x="0" y="0"/>
+            <a:ext cx="9144000" cy="54864"/>
+          </a:xfrm>
+          <a:prstGeom prst="rect">
+            <a:avLst/>
+          </a:prstGeom>
+          <a:solidFill>
+            <a:srgbClr val="2563EB"/>
+          </a:solidFill>
+          <a:ln>
+            <a:noFill/>
+          </a:ln>
+        </p:spPr>
+        <p:txBody>
+          <a:bodyPr/>
+          <a:lstStyle/>
+          <a:p>
+            <a:endParaRPr lang="en-US"/>
+          </a:p>
+        </p:txBody>
+      </p:sp>
+      <p:sp>
+        <p:nvSpPr>
+          <p:cNvPr id="102" name="Title"/>
+          <p:cNvSpPr/>
+          <p:nvPr/>
+        </p:nvSpPr>
+        <p:spPr>
+          <a:xfrm>
+            <a:off x="457200" y="137160"/>
+            <a:ext cx="8229600" cy="365760"/>
+          </a:xfrm>
+          <a:prstGeom prst="rect">
+            <a:avLst/>
+          </a:prstGeom>
+          <a:noFill/>
+          <a:ln>
+            <a:noFill/>
+          </a:ln>
+        </p:spPr>
+        <p:txBody>
+          <a:bodyPr wrap="square" lIns="0" tIns="0" rIns="0" bIns="0" rtlCol="0" anchor="b"/>
+          <a:lstStyle/>
+          <a:p>
+            <a:pPr marL="0" indent="0">
+              <a:buNone/>
+            </a:pPr>
+            <a:r>
+              <a:rPr lang="en-US" sz="2000" b="1" dirty="0">
+                <a:solidFill>
+                  <a:srgbClr val="FFFFFF"/>
+                </a:solidFill>
+                <a:latin typeface="Calibri" pitchFamily="34" charset="0"/>
+              </a:rPr>
+              <a:t>Step 3: Migration Complete</a:t>
+            </a:r>
+          </a:p>
+        </p:txBody>
+      </p:sp>
+      <p:sp>
+        <p:nvSpPr>
+          <p:cNvPr id="103" name="Subtitle"/>
+          <p:cNvSpPr/>
+          <p:nvPr/>
+        </p:nvSpPr>
+        <p:spPr>
+          <a:xfrm>
+            <a:off x="457200" y="502920"/>
+            <a:ext cx="8229600" cy="274320"/>
+          </a:xfrm>
+          <a:prstGeom prst="rect">
+            <a:avLst/>
+          </a:prstGeom>
+          <a:noFill/>
+          <a:ln>
+            <a:noFill/>
+          </a:ln>
+        </p:spPr>
+        <p:txBody>
+          <a:bodyPr wrap="square" lIns="0" tIns="0" rIns="0" bIns="0" rtlCol="0" anchor="t"/>
+          <a:lstStyle/>
+          <a:p>
+            <a:pPr marL="0" indent="0">
+              <a:buNone/>
+            </a:pPr>
+            <a:r>
+              <a:rPr lang="en-US" sz="1100" dirty="0">
+                <a:solidFill>
+                  <a:srgbClr val="93C5FD"/>
+                </a:solidFill>
+                <a:latin typeface="Calibri" pitchFamily="34" charset="0"/>
+              </a:rPr>
+              <a:t>Generated files, agent pipeline status, cost summary  &amp; actions</a:t>
+            </a:r>
+          </a:p>
+        </p:txBody>
+      </p:sp>
     </p:spTree>
     <p:extLst>
       <p:ext uri="{BB962C8B-B14F-4D97-AF65-F5344CB8AC3E}">
@@ -8414,14 +9352,148 @@
         </p:blipFill>
         <p:spPr>
           <a:xfrm>
-            <a:off x="0" y="392775"/>
-            <a:ext cx="9144000" cy="4357950"/>
+            <a:off x="274320" y="868680"/>
+            <a:ext cx="8595360" cy="4096512"/>
           </a:xfrm>
           <a:prstGeom prst="rect">
             <a:avLst/>
           </a:prstGeom>
         </p:spPr>
       </p:pic>
+      <p:sp>
+        <p:nvSpPr>
+          <p:cNvPr id="100" name="BgRect"/>
+          <p:cNvSpPr/>
+          <p:nvPr/>
+        </p:nvSpPr>
+        <p:spPr>
+          <a:xfrm>
+            <a:off x="0" y="0"/>
+            <a:ext cx="9144000" cy="5143500"/>
+          </a:xfrm>
+          <a:prstGeom prst="rect">
+            <a:avLst/>
+          </a:prstGeom>
+          <a:solidFill>
+            <a:srgbClr val="0B1A33"/>
+          </a:solidFill>
+          <a:ln>
+            <a:noFill/>
+          </a:ln>
+        </p:spPr>
+        <p:txBody>
+          <a:bodyPr/>
+          <a:lstStyle/>
+          <a:p>
+            <a:endParaRPr lang="en-US"/>
+          </a:p>
+        </p:txBody>
+      </p:sp>
+      <p:sp>
+        <p:nvSpPr>
+          <p:cNvPr id="101" name="AccentBar"/>
+          <p:cNvSpPr/>
+          <p:nvPr/>
+        </p:nvSpPr>
+        <p:spPr>
+          <a:xfrm>
+            <a:off x="0" y="0"/>
+            <a:ext cx="9144000" cy="54864"/>
+          </a:xfrm>
+          <a:prstGeom prst="rect">
+            <a:avLst/>
+          </a:prstGeom>
+          <a:solidFill>
+            <a:srgbClr val="2563EB"/>
+          </a:solidFill>
+          <a:ln>
+            <a:noFill/>
+          </a:ln>
+        </p:spPr>
+        <p:txBody>
+          <a:bodyPr/>
+          <a:lstStyle/>
+          <a:p>
+            <a:endParaRPr lang="en-US"/>
+          </a:p>
+        </p:txBody>
+      </p:sp>
+      <p:sp>
+        <p:nvSpPr>
+          <p:cNvPr id="102" name="Title"/>
+          <p:cNvSpPr/>
+          <p:nvPr/>
+        </p:nvSpPr>
+        <p:spPr>
+          <a:xfrm>
+            <a:off x="457200" y="137160"/>
+            <a:ext cx="8229600" cy="365760"/>
+          </a:xfrm>
+          <a:prstGeom prst="rect">
+            <a:avLst/>
+          </a:prstGeom>
+          <a:noFill/>
+          <a:ln>
+            <a:noFill/>
+          </a:ln>
+        </p:spPr>
+        <p:txBody>
+          <a:bodyPr wrap="square" lIns="0" tIns="0" rIns="0" bIns="0" rtlCol="0" anchor="b"/>
+          <a:lstStyle/>
+          <a:p>
+            <a:pPr marL="0" indent="0">
+              <a:buNone/>
+            </a:pPr>
+            <a:r>
+              <a:rPr lang="en-US" sz="2000" b="1" dirty="0">
+                <a:solidFill>
+                  <a:srgbClr val="FFFFFF"/>
+                </a:solidFill>
+                <a:latin typeface="Calibri" pitchFamily="34" charset="0"/>
+              </a:rPr>
+              <a:t>Step 4: Swagger Preview</a:t>
+            </a:r>
+          </a:p>
+        </p:txBody>
+      </p:sp>
+      <p:sp>
+        <p:nvSpPr>
+          <p:cNvPr id="103" name="Subtitle"/>
+          <p:cNvSpPr/>
+          <p:nvPr/>
+        </p:nvSpPr>
+        <p:spPr>
+          <a:xfrm>
+            <a:off x="457200" y="502920"/>
+            <a:ext cx="8229600" cy="274320"/>
+          </a:xfrm>
+          <a:prstGeom prst="rect">
+            <a:avLst/>
+          </a:prstGeom>
+          <a:noFill/>
+          <a:ln>
+            <a:noFill/>
+          </a:ln>
+        </p:spPr>
+        <p:txBody>
+          <a:bodyPr wrap="square" lIns="0" tIns="0" rIns="0" bIns="0" rtlCol="0" anchor="t"/>
+          <a:lstStyle/>
+          <a:p>
+            <a:pPr marL="0" indent="0">
+              <a:buNone/>
+            </a:pPr>
+            <a:r>
+              <a:rPr lang="en-US" sz="1100" dirty="0">
+                <a:solidFill>
+                  <a:srgbClr val="93C5FD"/>
+                </a:solidFill>
+                <a:latin typeface="Calibri" pitchFamily="34" charset="0"/>
+              </a:rPr>
+              <a:t>Auto-generated OpenAPI 3.0 spec with all endpoints documented</a:t>
+            </a:r>
+          </a:p>
+        </p:txBody>
+      </p:sp>
     </p:spTree>
     <p:extLst>
       <p:ext uri="{BB962C8B-B14F-4D97-AF65-F5344CB8AC3E}">
@@ -8474,14 +9546,148 @@
         </p:blipFill>
         <p:spPr>
           <a:xfrm>
-            <a:off x="0" y="398491"/>
-            <a:ext cx="9144000" cy="4346518"/>
+            <a:off x="274320" y="868680"/>
+            <a:ext cx="8595360" cy="4096512"/>
           </a:xfrm>
           <a:prstGeom prst="rect">
             <a:avLst/>
           </a:prstGeom>
         </p:spPr>
       </p:pic>
+      <p:sp>
+        <p:nvSpPr>
+          <p:cNvPr id="100" name="BgRect"/>
+          <p:cNvSpPr/>
+          <p:nvPr/>
+        </p:nvSpPr>
+        <p:spPr>
+          <a:xfrm>
+            <a:off x="0" y="0"/>
+            <a:ext cx="9144000" cy="5143500"/>
+          </a:xfrm>
+          <a:prstGeom prst="rect">
+            <a:avLst/>
+          </a:prstGeom>
+          <a:solidFill>
+            <a:srgbClr val="0B1A33"/>
+          </a:solidFill>
+          <a:ln>
+            <a:noFill/>
+          </a:ln>
+        </p:spPr>
+        <p:txBody>
+          <a:bodyPr/>
+          <a:lstStyle/>
+          <a:p>
+            <a:endParaRPr lang="en-US"/>
+          </a:p>
+        </p:txBody>
+      </p:sp>
+      <p:sp>
+        <p:nvSpPr>
+          <p:cNvPr id="101" name="AccentBar"/>
+          <p:cNvSpPr/>
+          <p:nvPr/>
+        </p:nvSpPr>
+        <p:spPr>
+          <a:xfrm>
+            <a:off x="0" y="0"/>
+            <a:ext cx="9144000" cy="54864"/>
+          </a:xfrm>
+          <a:prstGeom prst="rect">
+            <a:avLst/>
+          </a:prstGeom>
+          <a:solidFill>
+            <a:srgbClr val="2563EB"/>
+          </a:solidFill>
+          <a:ln>
+            <a:noFill/>
+          </a:ln>
+        </p:spPr>
+        <p:txBody>
+          <a:bodyPr/>
+          <a:lstStyle/>
+          <a:p>
+            <a:endParaRPr lang="en-US"/>
+          </a:p>
+        </p:txBody>
+      </p:sp>
+      <p:sp>
+        <p:nvSpPr>
+          <p:cNvPr id="102" name="Title"/>
+          <p:cNvSpPr/>
+          <p:nvPr/>
+        </p:nvSpPr>
+        <p:spPr>
+          <a:xfrm>
+            <a:off x="457200" y="137160"/>
+            <a:ext cx="8229600" cy="365760"/>
+          </a:xfrm>
+          <a:prstGeom prst="rect">
+            <a:avLst/>
+          </a:prstGeom>
+          <a:noFill/>
+          <a:ln>
+            <a:noFill/>
+          </a:ln>
+        </p:spPr>
+        <p:txBody>
+          <a:bodyPr wrap="square" lIns="0" tIns="0" rIns="0" bIns="0" rtlCol="0" anchor="b"/>
+          <a:lstStyle/>
+          <a:p>
+            <a:pPr marL="0" indent="0">
+              <a:buNone/>
+            </a:pPr>
+            <a:r>
+              <a:rPr lang="en-US" sz="2000" b="1" dirty="0">
+                <a:solidFill>
+                  <a:srgbClr val="FFFFFF"/>
+                </a:solidFill>
+                <a:latin typeface="Calibri" pitchFamily="34" charset="0"/>
+              </a:rPr>
+              <a:t>Step 5: Push to GitHub</a:t>
+            </a:r>
+          </a:p>
+        </p:txBody>
+      </p:sp>
+      <p:sp>
+        <p:nvSpPr>
+          <p:cNvPr id="103" name="Subtitle"/>
+          <p:cNvSpPr/>
+          <p:nvPr/>
+        </p:nvSpPr>
+        <p:spPr>
+          <a:xfrm>
+            <a:off x="457200" y="502920"/>
+            <a:ext cx="8229600" cy="274320"/>
+          </a:xfrm>
+          <a:prstGeom prst="rect">
+            <a:avLst/>
+          </a:prstGeom>
+          <a:noFill/>
+          <a:ln>
+            <a:noFill/>
+          </a:ln>
+        </p:spPr>
+        <p:txBody>
+          <a:bodyPr wrap="square" lIns="0" tIns="0" rIns="0" bIns="0" rtlCol="0" anchor="t"/>
+          <a:lstStyle/>
+          <a:p>
+            <a:pPr marL="0" indent="0">
+              <a:buNone/>
+            </a:pPr>
+            <a:r>
+              <a:rPr lang="en-US" sz="1100" dirty="0">
+                <a:solidFill>
+                  <a:srgbClr val="93C5FD"/>
+                </a:solidFill>
+                <a:latin typeface="Calibri" pitchFamily="34" charset="0"/>
+              </a:rPr>
+              <a:t>Connect GitHub token, configure repo, branch  &amp; push generated code</a:t>
+            </a:r>
+          </a:p>
+        </p:txBody>
+      </p:sp>
     </p:spTree>
     <p:extLst>
       <p:ext uri="{BB962C8B-B14F-4D97-AF65-F5344CB8AC3E}">

</xml_diff>

<commit_message>
Fix screenshot slides: header strip behind, images on top
- Replace full-screen BgRect with 0.9" header strip
- Reorder z-index: header shapes first, screenshot last
- Screenshots now fully visible below heading area

Co-Authored-By: Claude Opus 4.6 <noreply@anthropic.com>
</commit_message>
<xml_diff>
--- a/MuleSoft-to-SpringBoot-Migrator-Technical-Presentation.pptx
+++ b/MuleSoft-to-SpringBoot-Migrator-Technical-Presentation.pptx
@@ -1693,6 +1693,140 @@
           <a:chExt cx="0" cy="0"/>
         </a:xfrm>
       </p:grpSpPr>
+      <p:sp>
+        <p:nvSpPr>
+          <p:cNvPr id="100" name="HeaderStrip"/>
+          <p:cNvSpPr/>
+          <p:nvPr/>
+        </p:nvSpPr>
+        <p:spPr>
+          <a:xfrm>
+            <a:off x="0" y="0"/>
+            <a:ext cx="9144000" cy="822960"/>
+          </a:xfrm>
+          <a:prstGeom prst="rect">
+            <a:avLst/>
+          </a:prstGeom>
+          <a:solidFill>
+            <a:srgbClr val="0B1A33"/>
+          </a:solidFill>
+          <a:ln>
+            <a:noFill/>
+          </a:ln>
+        </p:spPr>
+        <p:txBody>
+          <a:bodyPr/>
+          <a:lstStyle/>
+          <a:p>
+            <a:endParaRPr lang="en-US"/>
+          </a:p>
+        </p:txBody>
+      </p:sp>
+      <p:sp>
+        <p:nvSpPr>
+          <p:cNvPr id="101" name="AccentBar"/>
+          <p:cNvSpPr/>
+          <p:nvPr/>
+        </p:nvSpPr>
+        <p:spPr>
+          <a:xfrm>
+            <a:off x="0" y="0"/>
+            <a:ext cx="9144000" cy="54864"/>
+          </a:xfrm>
+          <a:prstGeom prst="rect">
+            <a:avLst/>
+          </a:prstGeom>
+          <a:solidFill>
+            <a:srgbClr val="2563EB"/>
+          </a:solidFill>
+          <a:ln>
+            <a:noFill/>
+          </a:ln>
+        </p:spPr>
+        <p:txBody>
+          <a:bodyPr/>
+          <a:lstStyle/>
+          <a:p>
+            <a:endParaRPr lang="en-US"/>
+          </a:p>
+        </p:txBody>
+      </p:sp>
+      <p:sp>
+        <p:nvSpPr>
+          <p:cNvPr id="102" name="Title"/>
+          <p:cNvSpPr/>
+          <p:nvPr/>
+        </p:nvSpPr>
+        <p:spPr>
+          <a:xfrm>
+            <a:off x="457200" y="137160"/>
+            <a:ext cx="8229600" cy="365760"/>
+          </a:xfrm>
+          <a:prstGeom prst="rect">
+            <a:avLst/>
+          </a:prstGeom>
+          <a:noFill/>
+          <a:ln>
+            <a:noFill/>
+          </a:ln>
+        </p:spPr>
+        <p:txBody>
+          <a:bodyPr wrap="square" lIns="0" tIns="0" rIns="0" bIns="0" rtlCol="0" anchor="b"/>
+          <a:lstStyle/>
+          <a:p>
+            <a:pPr marL="0" indent="0">
+              <a:buNone/>
+            </a:pPr>
+            <a:r>
+              <a:rPr lang="en-US" sz="2000" b="1" dirty="0">
+                <a:solidFill>
+                  <a:srgbClr val="FFFFFF"/>
+                </a:solidFill>
+                <a:latin typeface="Calibri" pitchFamily="34" charset="0"/>
+              </a:rPr>
+              <a:t>Step 6: RAG Knowledge Base</a:t>
+            </a:r>
+          </a:p>
+        </p:txBody>
+      </p:sp>
+      <p:sp>
+        <p:nvSpPr>
+          <p:cNvPr id="103" name="Subtitle"/>
+          <p:cNvSpPr/>
+          <p:nvPr/>
+        </p:nvSpPr>
+        <p:spPr>
+          <a:xfrm>
+            <a:off x="457200" y="502920"/>
+            <a:ext cx="8229600" cy="274320"/>
+          </a:xfrm>
+          <a:prstGeom prst="rect">
+            <a:avLst/>
+          </a:prstGeom>
+          <a:noFill/>
+          <a:ln>
+            <a:noFill/>
+          </a:ln>
+        </p:spPr>
+        <p:txBody>
+          <a:bodyPr wrap="square" lIns="0" tIns="0" rIns="0" bIns="0" rtlCol="0" anchor="t"/>
+          <a:lstStyle/>
+          <a:p>
+            <a:pPr marL="0" indent="0">
+              <a:buNone/>
+            </a:pPr>
+            <a:r>
+              <a:rPr lang="en-US" sz="1100" dirty="0">
+                <a:solidFill>
+                  <a:srgbClr val="93C5FD"/>
+                </a:solidFill>
+                <a:latin typeface="Calibri" pitchFamily="34" charset="0"/>
+              </a:rPr>
+              <a:t>265 documents, 2650 embeddings powering AI migration agents</a:t>
+            </a:r>
+          </a:p>
+        </p:txBody>
+      </p:sp>
       <p:pic>
         <p:nvPicPr>
           <p:cNvPr id="3" name="Picture 2">
@@ -1723,140 +1857,6 @@
           </a:prstGeom>
         </p:spPr>
       </p:pic>
-      <p:sp>
-        <p:nvSpPr>
-          <p:cNvPr id="100" name="BgRect"/>
-          <p:cNvSpPr/>
-          <p:nvPr/>
-        </p:nvSpPr>
-        <p:spPr>
-          <a:xfrm>
-            <a:off x="0" y="0"/>
-            <a:ext cx="9144000" cy="5143500"/>
-          </a:xfrm>
-          <a:prstGeom prst="rect">
-            <a:avLst/>
-          </a:prstGeom>
-          <a:solidFill>
-            <a:srgbClr val="0B1A33"/>
-          </a:solidFill>
-          <a:ln>
-            <a:noFill/>
-          </a:ln>
-        </p:spPr>
-        <p:txBody>
-          <a:bodyPr/>
-          <a:lstStyle/>
-          <a:p>
-            <a:endParaRPr lang="en-US"/>
-          </a:p>
-        </p:txBody>
-      </p:sp>
-      <p:sp>
-        <p:nvSpPr>
-          <p:cNvPr id="101" name="AccentBar"/>
-          <p:cNvSpPr/>
-          <p:nvPr/>
-        </p:nvSpPr>
-        <p:spPr>
-          <a:xfrm>
-            <a:off x="0" y="0"/>
-            <a:ext cx="9144000" cy="54864"/>
-          </a:xfrm>
-          <a:prstGeom prst="rect">
-            <a:avLst/>
-          </a:prstGeom>
-          <a:solidFill>
-            <a:srgbClr val="2563EB"/>
-          </a:solidFill>
-          <a:ln>
-            <a:noFill/>
-          </a:ln>
-        </p:spPr>
-        <p:txBody>
-          <a:bodyPr/>
-          <a:lstStyle/>
-          <a:p>
-            <a:endParaRPr lang="en-US"/>
-          </a:p>
-        </p:txBody>
-      </p:sp>
-      <p:sp>
-        <p:nvSpPr>
-          <p:cNvPr id="102" name="Title"/>
-          <p:cNvSpPr/>
-          <p:nvPr/>
-        </p:nvSpPr>
-        <p:spPr>
-          <a:xfrm>
-            <a:off x="457200" y="137160"/>
-            <a:ext cx="8229600" cy="365760"/>
-          </a:xfrm>
-          <a:prstGeom prst="rect">
-            <a:avLst/>
-          </a:prstGeom>
-          <a:noFill/>
-          <a:ln>
-            <a:noFill/>
-          </a:ln>
-        </p:spPr>
-        <p:txBody>
-          <a:bodyPr wrap="square" lIns="0" tIns="0" rIns="0" bIns="0" rtlCol="0" anchor="b"/>
-          <a:lstStyle/>
-          <a:p>
-            <a:pPr marL="0" indent="0">
-              <a:buNone/>
-            </a:pPr>
-            <a:r>
-              <a:rPr lang="en-US" sz="2000" b="1" dirty="0">
-                <a:solidFill>
-                  <a:srgbClr val="FFFFFF"/>
-                </a:solidFill>
-                <a:latin typeface="Calibri" pitchFamily="34" charset="0"/>
-              </a:rPr>
-              <a:t>Step 6: RAG Knowledge Base</a:t>
-            </a:r>
-          </a:p>
-        </p:txBody>
-      </p:sp>
-      <p:sp>
-        <p:nvSpPr>
-          <p:cNvPr id="103" name="Subtitle"/>
-          <p:cNvSpPr/>
-          <p:nvPr/>
-        </p:nvSpPr>
-        <p:spPr>
-          <a:xfrm>
-            <a:off x="457200" y="502920"/>
-            <a:ext cx="8229600" cy="274320"/>
-          </a:xfrm>
-          <a:prstGeom prst="rect">
-            <a:avLst/>
-          </a:prstGeom>
-          <a:noFill/>
-          <a:ln>
-            <a:noFill/>
-          </a:ln>
-        </p:spPr>
-        <p:txBody>
-          <a:bodyPr wrap="square" lIns="0" tIns="0" rIns="0" bIns="0" rtlCol="0" anchor="t"/>
-          <a:lstStyle/>
-          <a:p>
-            <a:pPr marL="0" indent="0">
-              <a:buNone/>
-            </a:pPr>
-            <a:r>
-              <a:rPr lang="en-US" sz="1100" dirty="0">
-                <a:solidFill>
-                  <a:srgbClr val="93C5FD"/>
-                </a:solidFill>
-                <a:latin typeface="Calibri" pitchFamily="34" charset="0"/>
-              </a:rPr>
-              <a:t>265 documents, 2650 embeddings powering AI migration agents</a:t>
-            </a:r>
-          </a:p>
-        </p:txBody>
-      </p:sp>
     </p:spTree>
     <p:extLst>
       <p:ext uri="{BB962C8B-B14F-4D97-AF65-F5344CB8AC3E}">
@@ -1887,6 +1887,140 @@
           <a:chExt cx="0" cy="0"/>
         </a:xfrm>
       </p:grpSpPr>
+      <p:sp>
+        <p:nvSpPr>
+          <p:cNvPr id="100" name="HeaderStrip"/>
+          <p:cNvSpPr/>
+          <p:nvPr/>
+        </p:nvSpPr>
+        <p:spPr>
+          <a:xfrm>
+            <a:off x="0" y="0"/>
+            <a:ext cx="9144000" cy="822960"/>
+          </a:xfrm>
+          <a:prstGeom prst="rect">
+            <a:avLst/>
+          </a:prstGeom>
+          <a:solidFill>
+            <a:srgbClr val="0B1A33"/>
+          </a:solidFill>
+          <a:ln>
+            <a:noFill/>
+          </a:ln>
+        </p:spPr>
+        <p:txBody>
+          <a:bodyPr/>
+          <a:lstStyle/>
+          <a:p>
+            <a:endParaRPr lang="en-US"/>
+          </a:p>
+        </p:txBody>
+      </p:sp>
+      <p:sp>
+        <p:nvSpPr>
+          <p:cNvPr id="101" name="AccentBar"/>
+          <p:cNvSpPr/>
+          <p:nvPr/>
+        </p:nvSpPr>
+        <p:spPr>
+          <a:xfrm>
+            <a:off x="0" y="0"/>
+            <a:ext cx="9144000" cy="54864"/>
+          </a:xfrm>
+          <a:prstGeom prst="rect">
+            <a:avLst/>
+          </a:prstGeom>
+          <a:solidFill>
+            <a:srgbClr val="2563EB"/>
+          </a:solidFill>
+          <a:ln>
+            <a:noFill/>
+          </a:ln>
+        </p:spPr>
+        <p:txBody>
+          <a:bodyPr/>
+          <a:lstStyle/>
+          <a:p>
+            <a:endParaRPr lang="en-US"/>
+          </a:p>
+        </p:txBody>
+      </p:sp>
+      <p:sp>
+        <p:nvSpPr>
+          <p:cNvPr id="102" name="Title"/>
+          <p:cNvSpPr/>
+          <p:nvPr/>
+        </p:nvSpPr>
+        <p:spPr>
+          <a:xfrm>
+            <a:off x="457200" y="137160"/>
+            <a:ext cx="8229600" cy="365760"/>
+          </a:xfrm>
+          <a:prstGeom prst="rect">
+            <a:avLst/>
+          </a:prstGeom>
+          <a:noFill/>
+          <a:ln>
+            <a:noFill/>
+          </a:ln>
+        </p:spPr>
+        <p:txBody>
+          <a:bodyPr wrap="square" lIns="0" tIns="0" rIns="0" bIns="0" rtlCol="0" anchor="b"/>
+          <a:lstStyle/>
+          <a:p>
+            <a:pPr marL="0" indent="0">
+              <a:buNone/>
+            </a:pPr>
+            <a:r>
+              <a:rPr lang="en-US" sz="2000" b="1" dirty="0">
+                <a:solidFill>
+                  <a:srgbClr val="FFFFFF"/>
+                </a:solidFill>
+                <a:latin typeface="Calibri" pitchFamily="34" charset="0"/>
+              </a:rPr>
+              <a:t>Step 7: Validation Config</a:t>
+            </a:r>
+          </a:p>
+        </p:txBody>
+      </p:sp>
+      <p:sp>
+        <p:nvSpPr>
+          <p:cNvPr id="103" name="Subtitle"/>
+          <p:cNvSpPr/>
+          <p:nvPr/>
+        </p:nvSpPr>
+        <p:spPr>
+          <a:xfrm>
+            <a:off x="457200" y="502920"/>
+            <a:ext cx="8229600" cy="274320"/>
+          </a:xfrm>
+          <a:prstGeom prst="rect">
+            <a:avLst/>
+          </a:prstGeom>
+          <a:noFill/>
+          <a:ln>
+            <a:noFill/>
+          </a:ln>
+        </p:spPr>
+        <p:txBody>
+          <a:bodyPr wrap="square" lIns="0" tIns="0" rIns="0" bIns="0" rtlCol="0" anchor="t"/>
+          <a:lstStyle/>
+          <a:p>
+            <a:pPr marL="0" indent="0">
+              <a:buNone/>
+            </a:pPr>
+            <a:r>
+              <a:rPr lang="en-US" sz="1100" dirty="0">
+                <a:solidFill>
+                  <a:srgbClr val="93C5FD"/>
+                </a:solidFill>
+                <a:latin typeface="Calibri" pitchFamily="34" charset="0"/>
+              </a:rPr>
+              <a:t>Deployment settings, testing mode, MuleSoft base URL  &amp; endpoint list</a:t>
+            </a:r>
+          </a:p>
+        </p:txBody>
+      </p:sp>
       <p:pic>
         <p:nvPicPr>
           <p:cNvPr id="3" name="Picture 2">
@@ -1917,140 +2051,6 @@
           </a:prstGeom>
         </p:spPr>
       </p:pic>
-      <p:sp>
-        <p:nvSpPr>
-          <p:cNvPr id="100" name="BgRect"/>
-          <p:cNvSpPr/>
-          <p:nvPr/>
-        </p:nvSpPr>
-        <p:spPr>
-          <a:xfrm>
-            <a:off x="0" y="0"/>
-            <a:ext cx="9144000" cy="5143500"/>
-          </a:xfrm>
-          <a:prstGeom prst="rect">
-            <a:avLst/>
-          </a:prstGeom>
-          <a:solidFill>
-            <a:srgbClr val="0B1A33"/>
-          </a:solidFill>
-          <a:ln>
-            <a:noFill/>
-          </a:ln>
-        </p:spPr>
-        <p:txBody>
-          <a:bodyPr/>
-          <a:lstStyle/>
-          <a:p>
-            <a:endParaRPr lang="en-US"/>
-          </a:p>
-        </p:txBody>
-      </p:sp>
-      <p:sp>
-        <p:nvSpPr>
-          <p:cNvPr id="101" name="AccentBar"/>
-          <p:cNvSpPr/>
-          <p:nvPr/>
-        </p:nvSpPr>
-        <p:spPr>
-          <a:xfrm>
-            <a:off x="0" y="0"/>
-            <a:ext cx="9144000" cy="54864"/>
-          </a:xfrm>
-          <a:prstGeom prst="rect">
-            <a:avLst/>
-          </a:prstGeom>
-          <a:solidFill>
-            <a:srgbClr val="2563EB"/>
-          </a:solidFill>
-          <a:ln>
-            <a:noFill/>
-          </a:ln>
-        </p:spPr>
-        <p:txBody>
-          <a:bodyPr/>
-          <a:lstStyle/>
-          <a:p>
-            <a:endParaRPr lang="en-US"/>
-          </a:p>
-        </p:txBody>
-      </p:sp>
-      <p:sp>
-        <p:nvSpPr>
-          <p:cNvPr id="102" name="Title"/>
-          <p:cNvSpPr/>
-          <p:nvPr/>
-        </p:nvSpPr>
-        <p:spPr>
-          <a:xfrm>
-            <a:off x="457200" y="137160"/>
-            <a:ext cx="8229600" cy="365760"/>
-          </a:xfrm>
-          <a:prstGeom prst="rect">
-            <a:avLst/>
-          </a:prstGeom>
-          <a:noFill/>
-          <a:ln>
-            <a:noFill/>
-          </a:ln>
-        </p:spPr>
-        <p:txBody>
-          <a:bodyPr wrap="square" lIns="0" tIns="0" rIns="0" bIns="0" rtlCol="0" anchor="b"/>
-          <a:lstStyle/>
-          <a:p>
-            <a:pPr marL="0" indent="0">
-              <a:buNone/>
-            </a:pPr>
-            <a:r>
-              <a:rPr lang="en-US" sz="2000" b="1" dirty="0">
-                <a:solidFill>
-                  <a:srgbClr val="FFFFFF"/>
-                </a:solidFill>
-                <a:latin typeface="Calibri" pitchFamily="34" charset="0"/>
-              </a:rPr>
-              <a:t>Step 7: Validation Config</a:t>
-            </a:r>
-          </a:p>
-        </p:txBody>
-      </p:sp>
-      <p:sp>
-        <p:nvSpPr>
-          <p:cNvPr id="103" name="Subtitle"/>
-          <p:cNvSpPr/>
-          <p:nvPr/>
-        </p:nvSpPr>
-        <p:spPr>
-          <a:xfrm>
-            <a:off x="457200" y="502920"/>
-            <a:ext cx="8229600" cy="274320"/>
-          </a:xfrm>
-          <a:prstGeom prst="rect">
-            <a:avLst/>
-          </a:prstGeom>
-          <a:noFill/>
-          <a:ln>
-            <a:noFill/>
-          </a:ln>
-        </p:spPr>
-        <p:txBody>
-          <a:bodyPr wrap="square" lIns="0" tIns="0" rIns="0" bIns="0" rtlCol="0" anchor="t"/>
-          <a:lstStyle/>
-          <a:p>
-            <a:pPr marL="0" indent="0">
-              <a:buNone/>
-            </a:pPr>
-            <a:r>
-              <a:rPr lang="en-US" sz="1100" dirty="0">
-                <a:solidFill>
-                  <a:srgbClr val="93C5FD"/>
-                </a:solidFill>
-                <a:latin typeface="Calibri" pitchFamily="34" charset="0"/>
-              </a:rPr>
-              <a:t>Deployment settings, testing mode, MuleSoft base URL  &amp; endpoint list</a:t>
-            </a:r>
-          </a:p>
-        </p:txBody>
-      </p:sp>
     </p:spTree>
     <p:extLst>
       <p:ext uri="{BB962C8B-B14F-4D97-AF65-F5344CB8AC3E}">
@@ -2081,6 +2081,140 @@
           <a:chExt cx="0" cy="0"/>
         </a:xfrm>
       </p:grpSpPr>
+      <p:sp>
+        <p:nvSpPr>
+          <p:cNvPr id="100" name="HeaderStrip"/>
+          <p:cNvSpPr/>
+          <p:nvPr/>
+        </p:nvSpPr>
+        <p:spPr>
+          <a:xfrm>
+            <a:off x="0" y="0"/>
+            <a:ext cx="9144000" cy="822960"/>
+          </a:xfrm>
+          <a:prstGeom prst="rect">
+            <a:avLst/>
+          </a:prstGeom>
+          <a:solidFill>
+            <a:srgbClr val="0B1A33"/>
+          </a:solidFill>
+          <a:ln>
+            <a:noFill/>
+          </a:ln>
+        </p:spPr>
+        <p:txBody>
+          <a:bodyPr/>
+          <a:lstStyle/>
+          <a:p>
+            <a:endParaRPr lang="en-US"/>
+          </a:p>
+        </p:txBody>
+      </p:sp>
+      <p:sp>
+        <p:nvSpPr>
+          <p:cNvPr id="101" name="AccentBar"/>
+          <p:cNvSpPr/>
+          <p:nvPr/>
+        </p:nvSpPr>
+        <p:spPr>
+          <a:xfrm>
+            <a:off x="0" y="0"/>
+            <a:ext cx="9144000" cy="54864"/>
+          </a:xfrm>
+          <a:prstGeom prst="rect">
+            <a:avLst/>
+          </a:prstGeom>
+          <a:solidFill>
+            <a:srgbClr val="2563EB"/>
+          </a:solidFill>
+          <a:ln>
+            <a:noFill/>
+          </a:ln>
+        </p:spPr>
+        <p:txBody>
+          <a:bodyPr/>
+          <a:lstStyle/>
+          <a:p>
+            <a:endParaRPr lang="en-US"/>
+          </a:p>
+        </p:txBody>
+      </p:sp>
+      <p:sp>
+        <p:nvSpPr>
+          <p:cNvPr id="102" name="Title"/>
+          <p:cNvSpPr/>
+          <p:nvPr/>
+        </p:nvSpPr>
+        <p:spPr>
+          <a:xfrm>
+            <a:off x="457200" y="137160"/>
+            <a:ext cx="8229600" cy="365760"/>
+          </a:xfrm>
+          <a:prstGeom prst="rect">
+            <a:avLst/>
+          </a:prstGeom>
+          <a:noFill/>
+          <a:ln>
+            <a:noFill/>
+          </a:ln>
+        </p:spPr>
+        <p:txBody>
+          <a:bodyPr wrap="square" lIns="0" tIns="0" rIns="0" bIns="0" rtlCol="0" anchor="b"/>
+          <a:lstStyle/>
+          <a:p>
+            <a:pPr marL="0" indent="0">
+              <a:buNone/>
+            </a:pPr>
+            <a:r>
+              <a:rPr lang="en-US" sz="2000" b="1" dirty="0">
+                <a:solidFill>
+                  <a:srgbClr val="FFFFFF"/>
+                </a:solidFill>
+                <a:latin typeface="Calibri" pitchFamily="34" charset="0"/>
+              </a:rPr>
+              <a:t>Step 8: Validation Running</a:t>
+            </a:r>
+          </a:p>
+        </p:txBody>
+      </p:sp>
+      <p:sp>
+        <p:nvSpPr>
+          <p:cNvPr id="103" name="Subtitle"/>
+          <p:cNvSpPr/>
+          <p:nvPr/>
+        </p:nvSpPr>
+        <p:spPr>
+          <a:xfrm>
+            <a:off x="457200" y="502920"/>
+            <a:ext cx="8229600" cy="274320"/>
+          </a:xfrm>
+          <a:prstGeom prst="rect">
+            <a:avLst/>
+          </a:prstGeom>
+          <a:noFill/>
+          <a:ln>
+            <a:noFill/>
+          </a:ln>
+        </p:spPr>
+        <p:txBody>
+          <a:bodyPr wrap="square" lIns="0" tIns="0" rIns="0" bIns="0" rtlCol="0" anchor="t"/>
+          <a:lstStyle/>
+          <a:p>
+            <a:pPr marL="0" indent="0">
+              <a:buNone/>
+            </a:pPr>
+            <a:r>
+              <a:rPr lang="en-US" sz="1100" dirty="0">
+                <a:solidFill>
+                  <a:srgbClr val="93C5FD"/>
+                </a:solidFill>
+                <a:latin typeface="Calibri" pitchFamily="34" charset="0"/>
+              </a:rPr>
+              <a:t>Docker build, ACI deploy, health check  &amp; container logs</a:t>
+            </a:r>
+          </a:p>
+        </p:txBody>
+      </p:sp>
       <p:pic>
         <p:nvPicPr>
           <p:cNvPr id="3" name="Picture 2">
@@ -2111,140 +2245,6 @@
           </a:prstGeom>
         </p:spPr>
       </p:pic>
-      <p:sp>
-        <p:nvSpPr>
-          <p:cNvPr id="100" name="BgRect"/>
-          <p:cNvSpPr/>
-          <p:nvPr/>
-        </p:nvSpPr>
-        <p:spPr>
-          <a:xfrm>
-            <a:off x="0" y="0"/>
-            <a:ext cx="9144000" cy="5143500"/>
-          </a:xfrm>
-          <a:prstGeom prst="rect">
-            <a:avLst/>
-          </a:prstGeom>
-          <a:solidFill>
-            <a:srgbClr val="0B1A33"/>
-          </a:solidFill>
-          <a:ln>
-            <a:noFill/>
-          </a:ln>
-        </p:spPr>
-        <p:txBody>
-          <a:bodyPr/>
-          <a:lstStyle/>
-          <a:p>
-            <a:endParaRPr lang="en-US"/>
-          </a:p>
-        </p:txBody>
-      </p:sp>
-      <p:sp>
-        <p:nvSpPr>
-          <p:cNvPr id="101" name="AccentBar"/>
-          <p:cNvSpPr/>
-          <p:nvPr/>
-        </p:nvSpPr>
-        <p:spPr>
-          <a:xfrm>
-            <a:off x="0" y="0"/>
-            <a:ext cx="9144000" cy="54864"/>
-          </a:xfrm>
-          <a:prstGeom prst="rect">
-            <a:avLst/>
-          </a:prstGeom>
-          <a:solidFill>
-            <a:srgbClr val="2563EB"/>
-          </a:solidFill>
-          <a:ln>
-            <a:noFill/>
-          </a:ln>
-        </p:spPr>
-        <p:txBody>
-          <a:bodyPr/>
-          <a:lstStyle/>
-          <a:p>
-            <a:endParaRPr lang="en-US"/>
-          </a:p>
-        </p:txBody>
-      </p:sp>
-      <p:sp>
-        <p:nvSpPr>
-          <p:cNvPr id="102" name="Title"/>
-          <p:cNvSpPr/>
-          <p:nvPr/>
-        </p:nvSpPr>
-        <p:spPr>
-          <a:xfrm>
-            <a:off x="457200" y="137160"/>
-            <a:ext cx="8229600" cy="365760"/>
-          </a:xfrm>
-          <a:prstGeom prst="rect">
-            <a:avLst/>
-          </a:prstGeom>
-          <a:noFill/>
-          <a:ln>
-            <a:noFill/>
-          </a:ln>
-        </p:spPr>
-        <p:txBody>
-          <a:bodyPr wrap="square" lIns="0" tIns="0" rIns="0" bIns="0" rtlCol="0" anchor="b"/>
-          <a:lstStyle/>
-          <a:p>
-            <a:pPr marL="0" indent="0">
-              <a:buNone/>
-            </a:pPr>
-            <a:r>
-              <a:rPr lang="en-US" sz="2000" b="1" dirty="0">
-                <a:solidFill>
-                  <a:srgbClr val="FFFFFF"/>
-                </a:solidFill>
-                <a:latin typeface="Calibri" pitchFamily="34" charset="0"/>
-              </a:rPr>
-              <a:t>Step 8: Validation Running</a:t>
-            </a:r>
-          </a:p>
-        </p:txBody>
-      </p:sp>
-      <p:sp>
-        <p:nvSpPr>
-          <p:cNvPr id="103" name="Subtitle"/>
-          <p:cNvSpPr/>
-          <p:nvPr/>
-        </p:nvSpPr>
-        <p:spPr>
-          <a:xfrm>
-            <a:off x="457200" y="502920"/>
-            <a:ext cx="8229600" cy="274320"/>
-          </a:xfrm>
-          <a:prstGeom prst="rect">
-            <a:avLst/>
-          </a:prstGeom>
-          <a:noFill/>
-          <a:ln>
-            <a:noFill/>
-          </a:ln>
-        </p:spPr>
-        <p:txBody>
-          <a:bodyPr wrap="square" lIns="0" tIns="0" rIns="0" bIns="0" rtlCol="0" anchor="t"/>
-          <a:lstStyle/>
-          <a:p>
-            <a:pPr marL="0" indent="0">
-              <a:buNone/>
-            </a:pPr>
-            <a:r>
-              <a:rPr lang="en-US" sz="1100" dirty="0">
-                <a:solidFill>
-                  <a:srgbClr val="93C5FD"/>
-                </a:solidFill>
-                <a:latin typeface="Calibri" pitchFamily="34" charset="0"/>
-              </a:rPr>
-              <a:t>Docker build, ACI deploy, health check  &amp; container logs</a:t>
-            </a:r>
-          </a:p>
-        </p:txBody>
-      </p:sp>
     </p:spTree>
     <p:extLst>
       <p:ext uri="{BB962C8B-B14F-4D97-AF65-F5344CB8AC3E}">
@@ -2275,6 +2275,140 @@
           <a:chExt cx="0" cy="0"/>
         </a:xfrm>
       </p:grpSpPr>
+      <p:sp>
+        <p:nvSpPr>
+          <p:cNvPr id="100" name="HeaderStrip"/>
+          <p:cNvSpPr/>
+          <p:nvPr/>
+        </p:nvSpPr>
+        <p:spPr>
+          <a:xfrm>
+            <a:off x="0" y="0"/>
+            <a:ext cx="9144000" cy="822960"/>
+          </a:xfrm>
+          <a:prstGeom prst="rect">
+            <a:avLst/>
+          </a:prstGeom>
+          <a:solidFill>
+            <a:srgbClr val="0B1A33"/>
+          </a:solidFill>
+          <a:ln>
+            <a:noFill/>
+          </a:ln>
+        </p:spPr>
+        <p:txBody>
+          <a:bodyPr/>
+          <a:lstStyle/>
+          <a:p>
+            <a:endParaRPr lang="en-US"/>
+          </a:p>
+        </p:txBody>
+      </p:sp>
+      <p:sp>
+        <p:nvSpPr>
+          <p:cNvPr id="101" name="AccentBar"/>
+          <p:cNvSpPr/>
+          <p:nvPr/>
+        </p:nvSpPr>
+        <p:spPr>
+          <a:xfrm>
+            <a:off x="0" y="0"/>
+            <a:ext cx="9144000" cy="54864"/>
+          </a:xfrm>
+          <a:prstGeom prst="rect">
+            <a:avLst/>
+          </a:prstGeom>
+          <a:solidFill>
+            <a:srgbClr val="2563EB"/>
+          </a:solidFill>
+          <a:ln>
+            <a:noFill/>
+          </a:ln>
+        </p:spPr>
+        <p:txBody>
+          <a:bodyPr/>
+          <a:lstStyle/>
+          <a:p>
+            <a:endParaRPr lang="en-US"/>
+          </a:p>
+        </p:txBody>
+      </p:sp>
+      <p:sp>
+        <p:nvSpPr>
+          <p:cNvPr id="102" name="Title"/>
+          <p:cNvSpPr/>
+          <p:nvPr/>
+        </p:nvSpPr>
+        <p:spPr>
+          <a:xfrm>
+            <a:off x="457200" y="137160"/>
+            <a:ext cx="8229600" cy="365760"/>
+          </a:xfrm>
+          <a:prstGeom prst="rect">
+            <a:avLst/>
+          </a:prstGeom>
+          <a:noFill/>
+          <a:ln>
+            <a:noFill/>
+          </a:ln>
+        </p:spPr>
+        <p:txBody>
+          <a:bodyPr wrap="square" lIns="0" tIns="0" rIns="0" bIns="0" rtlCol="0" anchor="b"/>
+          <a:lstStyle/>
+          <a:p>
+            <a:pPr marL="0" indent="0">
+              <a:buNone/>
+            </a:pPr>
+            <a:r>
+              <a:rPr lang="en-US" sz="2000" b="1" dirty="0">
+                <a:solidFill>
+                  <a:srgbClr val="FFFFFF"/>
+                </a:solidFill>
+                <a:latin typeface="Calibri" pitchFamily="34" charset="0"/>
+              </a:rPr>
+              <a:t>Step 9: API Comparison</a:t>
+            </a:r>
+          </a:p>
+        </p:txBody>
+      </p:sp>
+      <p:sp>
+        <p:nvSpPr>
+          <p:cNvPr id="103" name="Subtitle"/>
+          <p:cNvSpPr/>
+          <p:nvPr/>
+        </p:nvSpPr>
+        <p:spPr>
+          <a:xfrm>
+            <a:off x="457200" y="502920"/>
+            <a:ext cx="8229600" cy="274320"/>
+          </a:xfrm>
+          <a:prstGeom prst="rect">
+            <a:avLst/>
+          </a:prstGeom>
+          <a:noFill/>
+          <a:ln>
+            <a:noFill/>
+          </a:ln>
+        </p:spPr>
+        <p:txBody>
+          <a:bodyPr wrap="square" lIns="0" tIns="0" rIns="0" bIns="0" rtlCol="0" anchor="t"/>
+          <a:lstStyle/>
+          <a:p>
+            <a:pPr marL="0" indent="0">
+              <a:buNone/>
+            </a:pPr>
+            <a:r>
+              <a:rPr lang="en-US" sz="1100" dirty="0">
+                <a:solidFill>
+                  <a:srgbClr val="93C5FD"/>
+                </a:solidFill>
+                <a:latin typeface="Calibri" pitchFamily="34" charset="0"/>
+              </a:rPr>
+              <a:t>9/9 endpoints matched — MuleSoft vs Spring Boot side-by-side</a:t>
+            </a:r>
+          </a:p>
+        </p:txBody>
+      </p:sp>
       <p:pic>
         <p:nvPicPr>
           <p:cNvPr id="3" name="Picture 2">
@@ -2305,140 +2439,6 @@
           </a:prstGeom>
         </p:spPr>
       </p:pic>
-      <p:sp>
-        <p:nvSpPr>
-          <p:cNvPr id="100" name="BgRect"/>
-          <p:cNvSpPr/>
-          <p:nvPr/>
-        </p:nvSpPr>
-        <p:spPr>
-          <a:xfrm>
-            <a:off x="0" y="0"/>
-            <a:ext cx="9144000" cy="5143500"/>
-          </a:xfrm>
-          <a:prstGeom prst="rect">
-            <a:avLst/>
-          </a:prstGeom>
-          <a:solidFill>
-            <a:srgbClr val="0B1A33"/>
-          </a:solidFill>
-          <a:ln>
-            <a:noFill/>
-          </a:ln>
-        </p:spPr>
-        <p:txBody>
-          <a:bodyPr/>
-          <a:lstStyle/>
-          <a:p>
-            <a:endParaRPr lang="en-US"/>
-          </a:p>
-        </p:txBody>
-      </p:sp>
-      <p:sp>
-        <p:nvSpPr>
-          <p:cNvPr id="101" name="AccentBar"/>
-          <p:cNvSpPr/>
-          <p:nvPr/>
-        </p:nvSpPr>
-        <p:spPr>
-          <a:xfrm>
-            <a:off x="0" y="0"/>
-            <a:ext cx="9144000" cy="54864"/>
-          </a:xfrm>
-          <a:prstGeom prst="rect">
-            <a:avLst/>
-          </a:prstGeom>
-          <a:solidFill>
-            <a:srgbClr val="2563EB"/>
-          </a:solidFill>
-          <a:ln>
-            <a:noFill/>
-          </a:ln>
-        </p:spPr>
-        <p:txBody>
-          <a:bodyPr/>
-          <a:lstStyle/>
-          <a:p>
-            <a:endParaRPr lang="en-US"/>
-          </a:p>
-        </p:txBody>
-      </p:sp>
-      <p:sp>
-        <p:nvSpPr>
-          <p:cNvPr id="102" name="Title"/>
-          <p:cNvSpPr/>
-          <p:nvPr/>
-        </p:nvSpPr>
-        <p:spPr>
-          <a:xfrm>
-            <a:off x="457200" y="137160"/>
-            <a:ext cx="8229600" cy="365760"/>
-          </a:xfrm>
-          <a:prstGeom prst="rect">
-            <a:avLst/>
-          </a:prstGeom>
-          <a:noFill/>
-          <a:ln>
-            <a:noFill/>
-          </a:ln>
-        </p:spPr>
-        <p:txBody>
-          <a:bodyPr wrap="square" lIns="0" tIns="0" rIns="0" bIns="0" rtlCol="0" anchor="b"/>
-          <a:lstStyle/>
-          <a:p>
-            <a:pPr marL="0" indent="0">
-              <a:buNone/>
-            </a:pPr>
-            <a:r>
-              <a:rPr lang="en-US" sz="2000" b="1" dirty="0">
-                <a:solidFill>
-                  <a:srgbClr val="FFFFFF"/>
-                </a:solidFill>
-                <a:latin typeface="Calibri" pitchFamily="34" charset="0"/>
-              </a:rPr>
-              <a:t>Step 9: API Comparison</a:t>
-            </a:r>
-          </a:p>
-        </p:txBody>
-      </p:sp>
-      <p:sp>
-        <p:nvSpPr>
-          <p:cNvPr id="103" name="Subtitle"/>
-          <p:cNvSpPr/>
-          <p:nvPr/>
-        </p:nvSpPr>
-        <p:spPr>
-          <a:xfrm>
-            <a:off x="457200" y="502920"/>
-            <a:ext cx="8229600" cy="274320"/>
-          </a:xfrm>
-          <a:prstGeom prst="rect">
-            <a:avLst/>
-          </a:prstGeom>
-          <a:noFill/>
-          <a:ln>
-            <a:noFill/>
-          </a:ln>
-        </p:spPr>
-        <p:txBody>
-          <a:bodyPr wrap="square" lIns="0" tIns="0" rIns="0" bIns="0" rtlCol="0" anchor="t"/>
-          <a:lstStyle/>
-          <a:p>
-            <a:pPr marL="0" indent="0">
-              <a:buNone/>
-            </a:pPr>
-            <a:r>
-              <a:rPr lang="en-US" sz="1100" dirty="0">
-                <a:solidFill>
-                  <a:srgbClr val="93C5FD"/>
-                </a:solidFill>
-                <a:latin typeface="Calibri" pitchFamily="34" charset="0"/>
-              </a:rPr>
-              <a:t>9/9 endpoints matched — MuleSoft vs Spring Boot side-by-side</a:t>
-            </a:r>
-          </a:p>
-        </p:txBody>
-      </p:sp>
     </p:spTree>
     <p:extLst>
       <p:ext uri="{BB962C8B-B14F-4D97-AF65-F5344CB8AC3E}">
@@ -8748,6 +8748,140 @@
           <a:chExt cx="0" cy="0"/>
         </a:xfrm>
       </p:grpSpPr>
+      <p:sp>
+        <p:nvSpPr>
+          <p:cNvPr id="100" name="HeaderStrip"/>
+          <p:cNvSpPr/>
+          <p:nvPr/>
+        </p:nvSpPr>
+        <p:spPr>
+          <a:xfrm>
+            <a:off x="0" y="0"/>
+            <a:ext cx="9144000" cy="822960"/>
+          </a:xfrm>
+          <a:prstGeom prst="rect">
+            <a:avLst/>
+          </a:prstGeom>
+          <a:solidFill>
+            <a:srgbClr val="0B1A33"/>
+          </a:solidFill>
+          <a:ln>
+            <a:noFill/>
+          </a:ln>
+        </p:spPr>
+        <p:txBody>
+          <a:bodyPr/>
+          <a:lstStyle/>
+          <a:p>
+            <a:endParaRPr lang="en-US"/>
+          </a:p>
+        </p:txBody>
+      </p:sp>
+      <p:sp>
+        <p:nvSpPr>
+          <p:cNvPr id="101" name="AccentBar"/>
+          <p:cNvSpPr/>
+          <p:nvPr/>
+        </p:nvSpPr>
+        <p:spPr>
+          <a:xfrm>
+            <a:off x="0" y="0"/>
+            <a:ext cx="9144000" cy="54864"/>
+          </a:xfrm>
+          <a:prstGeom prst="rect">
+            <a:avLst/>
+          </a:prstGeom>
+          <a:solidFill>
+            <a:srgbClr val="2563EB"/>
+          </a:solidFill>
+          <a:ln>
+            <a:noFill/>
+          </a:ln>
+        </p:spPr>
+        <p:txBody>
+          <a:bodyPr/>
+          <a:lstStyle/>
+          <a:p>
+            <a:endParaRPr lang="en-US"/>
+          </a:p>
+        </p:txBody>
+      </p:sp>
+      <p:sp>
+        <p:nvSpPr>
+          <p:cNvPr id="102" name="Title"/>
+          <p:cNvSpPr/>
+          <p:nvPr/>
+        </p:nvSpPr>
+        <p:spPr>
+          <a:xfrm>
+            <a:off x="457200" y="137160"/>
+            <a:ext cx="8229600" cy="365760"/>
+          </a:xfrm>
+          <a:prstGeom prst="rect">
+            <a:avLst/>
+          </a:prstGeom>
+          <a:noFill/>
+          <a:ln>
+            <a:noFill/>
+          </a:ln>
+        </p:spPr>
+        <p:txBody>
+          <a:bodyPr wrap="square" lIns="0" tIns="0" rIns="0" bIns="0" rtlCol="0" anchor="b"/>
+          <a:lstStyle/>
+          <a:p>
+            <a:pPr marL="0" indent="0">
+              <a:buNone/>
+            </a:pPr>
+            <a:r>
+              <a:rPr lang="en-US" sz="2000" b="1" dirty="0">
+                <a:solidFill>
+                  <a:srgbClr val="FFFFFF"/>
+                </a:solidFill>
+                <a:latin typeface="Calibri" pitchFamily="34" charset="0"/>
+              </a:rPr>
+              <a:t>Step 1: Dashboard</a:t>
+            </a:r>
+          </a:p>
+        </p:txBody>
+      </p:sp>
+      <p:sp>
+        <p:nvSpPr>
+          <p:cNvPr id="103" name="Subtitle"/>
+          <p:cNvSpPr/>
+          <p:nvPr/>
+        </p:nvSpPr>
+        <p:spPr>
+          <a:xfrm>
+            <a:off x="457200" y="502920"/>
+            <a:ext cx="8229600" cy="274320"/>
+          </a:xfrm>
+          <a:prstGeom prst="rect">
+            <a:avLst/>
+          </a:prstGeom>
+          <a:noFill/>
+          <a:ln>
+            <a:noFill/>
+          </a:ln>
+        </p:spPr>
+        <p:txBody>
+          <a:bodyPr wrap="square" lIns="0" tIns="0" rIns="0" bIns="0" rtlCol="0" anchor="t"/>
+          <a:lstStyle/>
+          <a:p>
+            <a:pPr marL="0" indent="0">
+              <a:buNone/>
+            </a:pPr>
+            <a:r>
+              <a:rPr lang="en-US" sz="1100" dirty="0">
+                <a:solidFill>
+                  <a:srgbClr val="93C5FD"/>
+                </a:solidFill>
+                <a:latin typeface="Calibri" pitchFamily="34" charset="0"/>
+              </a:rPr>
+              <a:t>Migration overview, stats, recent activity  &amp; weekly trends</a:t>
+            </a:r>
+          </a:p>
+        </p:txBody>
+      </p:sp>
       <p:pic>
         <p:nvPicPr>
           <p:cNvPr id="3" name="Picture 2">
@@ -8778,140 +8912,6 @@
           </a:prstGeom>
         </p:spPr>
       </p:pic>
-      <p:sp>
-        <p:nvSpPr>
-          <p:cNvPr id="100" name="BgRect"/>
-          <p:cNvSpPr/>
-          <p:nvPr/>
-        </p:nvSpPr>
-        <p:spPr>
-          <a:xfrm>
-            <a:off x="0" y="0"/>
-            <a:ext cx="9144000" cy="5143500"/>
-          </a:xfrm>
-          <a:prstGeom prst="rect">
-            <a:avLst/>
-          </a:prstGeom>
-          <a:solidFill>
-            <a:srgbClr val="0B1A33"/>
-          </a:solidFill>
-          <a:ln>
-            <a:noFill/>
-          </a:ln>
-        </p:spPr>
-        <p:txBody>
-          <a:bodyPr/>
-          <a:lstStyle/>
-          <a:p>
-            <a:endParaRPr lang="en-US"/>
-          </a:p>
-        </p:txBody>
-      </p:sp>
-      <p:sp>
-        <p:nvSpPr>
-          <p:cNvPr id="101" name="AccentBar"/>
-          <p:cNvSpPr/>
-          <p:nvPr/>
-        </p:nvSpPr>
-        <p:spPr>
-          <a:xfrm>
-            <a:off x="0" y="0"/>
-            <a:ext cx="9144000" cy="54864"/>
-          </a:xfrm>
-          <a:prstGeom prst="rect">
-            <a:avLst/>
-          </a:prstGeom>
-          <a:solidFill>
-            <a:srgbClr val="2563EB"/>
-          </a:solidFill>
-          <a:ln>
-            <a:noFill/>
-          </a:ln>
-        </p:spPr>
-        <p:txBody>
-          <a:bodyPr/>
-          <a:lstStyle/>
-          <a:p>
-            <a:endParaRPr lang="en-US"/>
-          </a:p>
-        </p:txBody>
-      </p:sp>
-      <p:sp>
-        <p:nvSpPr>
-          <p:cNvPr id="102" name="Title"/>
-          <p:cNvSpPr/>
-          <p:nvPr/>
-        </p:nvSpPr>
-        <p:spPr>
-          <a:xfrm>
-            <a:off x="457200" y="137160"/>
-            <a:ext cx="8229600" cy="365760"/>
-          </a:xfrm>
-          <a:prstGeom prst="rect">
-            <a:avLst/>
-          </a:prstGeom>
-          <a:noFill/>
-          <a:ln>
-            <a:noFill/>
-          </a:ln>
-        </p:spPr>
-        <p:txBody>
-          <a:bodyPr wrap="square" lIns="0" tIns="0" rIns="0" bIns="0" rtlCol="0" anchor="b"/>
-          <a:lstStyle/>
-          <a:p>
-            <a:pPr marL="0" indent="0">
-              <a:buNone/>
-            </a:pPr>
-            <a:r>
-              <a:rPr lang="en-US" sz="2000" b="1" dirty="0">
-                <a:solidFill>
-                  <a:srgbClr val="FFFFFF"/>
-                </a:solidFill>
-                <a:latin typeface="Calibri" pitchFamily="34" charset="0"/>
-              </a:rPr>
-              <a:t>Step 1: Dashboard</a:t>
-            </a:r>
-          </a:p>
-        </p:txBody>
-      </p:sp>
-      <p:sp>
-        <p:nvSpPr>
-          <p:cNvPr id="103" name="Subtitle"/>
-          <p:cNvSpPr/>
-          <p:nvPr/>
-        </p:nvSpPr>
-        <p:spPr>
-          <a:xfrm>
-            <a:off x="457200" y="502920"/>
-            <a:ext cx="8229600" cy="274320"/>
-          </a:xfrm>
-          <a:prstGeom prst="rect">
-            <a:avLst/>
-          </a:prstGeom>
-          <a:noFill/>
-          <a:ln>
-            <a:noFill/>
-          </a:ln>
-        </p:spPr>
-        <p:txBody>
-          <a:bodyPr wrap="square" lIns="0" tIns="0" rIns="0" bIns="0" rtlCol="0" anchor="t"/>
-          <a:lstStyle/>
-          <a:p>
-            <a:pPr marL="0" indent="0">
-              <a:buNone/>
-            </a:pPr>
-            <a:r>
-              <a:rPr lang="en-US" sz="1100" dirty="0">
-                <a:solidFill>
-                  <a:srgbClr val="93C5FD"/>
-                </a:solidFill>
-                <a:latin typeface="Calibri" pitchFamily="34" charset="0"/>
-              </a:rPr>
-              <a:t>Migration overview, stats, recent activity  &amp; weekly trends</a:t>
-            </a:r>
-          </a:p>
-        </p:txBody>
-      </p:sp>
     </p:spTree>
     <p:extLst>
       <p:ext uri="{BB962C8B-B14F-4D97-AF65-F5344CB8AC3E}">
@@ -8942,6 +8942,140 @@
           <a:chExt cx="0" cy="0"/>
         </a:xfrm>
       </p:grpSpPr>
+      <p:sp>
+        <p:nvSpPr>
+          <p:cNvPr id="100" name="HeaderStrip"/>
+          <p:cNvSpPr/>
+          <p:nvPr/>
+        </p:nvSpPr>
+        <p:spPr>
+          <a:xfrm>
+            <a:off x="0" y="0"/>
+            <a:ext cx="9144000" cy="822960"/>
+          </a:xfrm>
+          <a:prstGeom prst="rect">
+            <a:avLst/>
+          </a:prstGeom>
+          <a:solidFill>
+            <a:srgbClr val="0B1A33"/>
+          </a:solidFill>
+          <a:ln>
+            <a:noFill/>
+          </a:ln>
+        </p:spPr>
+        <p:txBody>
+          <a:bodyPr/>
+          <a:lstStyle/>
+          <a:p>
+            <a:endParaRPr lang="en-US"/>
+          </a:p>
+        </p:txBody>
+      </p:sp>
+      <p:sp>
+        <p:nvSpPr>
+          <p:cNvPr id="101" name="AccentBar"/>
+          <p:cNvSpPr/>
+          <p:nvPr/>
+        </p:nvSpPr>
+        <p:spPr>
+          <a:xfrm>
+            <a:off x="0" y="0"/>
+            <a:ext cx="9144000" cy="54864"/>
+          </a:xfrm>
+          <a:prstGeom prst="rect">
+            <a:avLst/>
+          </a:prstGeom>
+          <a:solidFill>
+            <a:srgbClr val="2563EB"/>
+          </a:solidFill>
+          <a:ln>
+            <a:noFill/>
+          </a:ln>
+        </p:spPr>
+        <p:txBody>
+          <a:bodyPr/>
+          <a:lstStyle/>
+          <a:p>
+            <a:endParaRPr lang="en-US"/>
+          </a:p>
+        </p:txBody>
+      </p:sp>
+      <p:sp>
+        <p:nvSpPr>
+          <p:cNvPr id="102" name="Title"/>
+          <p:cNvSpPr/>
+          <p:nvPr/>
+        </p:nvSpPr>
+        <p:spPr>
+          <a:xfrm>
+            <a:off x="457200" y="137160"/>
+            <a:ext cx="8229600" cy="365760"/>
+          </a:xfrm>
+          <a:prstGeom prst="rect">
+            <a:avLst/>
+          </a:prstGeom>
+          <a:noFill/>
+          <a:ln>
+            <a:noFill/>
+          </a:ln>
+        </p:spPr>
+        <p:txBody>
+          <a:bodyPr wrap="square" lIns="0" tIns="0" rIns="0" bIns="0" rtlCol="0" anchor="b"/>
+          <a:lstStyle/>
+          <a:p>
+            <a:pPr marL="0" indent="0">
+              <a:buNone/>
+            </a:pPr>
+            <a:r>
+              <a:rPr lang="en-US" sz="2000" b="1" dirty="0">
+                <a:solidFill>
+                  <a:srgbClr val="FFFFFF"/>
+                </a:solidFill>
+                <a:latin typeface="Calibri" pitchFamily="34" charset="0"/>
+              </a:rPr>
+              <a:t>Step 2: Upload  &amp; Configure</a:t>
+            </a:r>
+          </a:p>
+        </p:txBody>
+      </p:sp>
+      <p:sp>
+        <p:nvSpPr>
+          <p:cNvPr id="103" name="Subtitle"/>
+          <p:cNvSpPr/>
+          <p:nvPr/>
+        </p:nvSpPr>
+        <p:spPr>
+          <a:xfrm>
+            <a:off x="457200" y="502920"/>
+            <a:ext cx="8229600" cy="274320"/>
+          </a:xfrm>
+          <a:prstGeom prst="rect">
+            <a:avLst/>
+          </a:prstGeom>
+          <a:noFill/>
+          <a:ln>
+            <a:noFill/>
+          </a:ln>
+        </p:spPr>
+        <p:txBody>
+          <a:bodyPr wrap="square" lIns="0" tIns="0" rIns="0" bIns="0" rtlCol="0" anchor="t"/>
+          <a:lstStyle/>
+          <a:p>
+            <a:pPr marL="0" indent="0">
+              <a:buNone/>
+            </a:pPr>
+            <a:r>
+              <a:rPr lang="en-US" sz="1100" dirty="0">
+                <a:solidFill>
+                  <a:srgbClr val="93C5FD"/>
+                </a:solidFill>
+                <a:latin typeface="Calibri" pitchFamily="34" charset="0"/>
+              </a:rPr>
+              <a:t>Drag  &amp; drop MuleSoft project, set migration options, enable AI enhancement</a:t>
+            </a:r>
+          </a:p>
+        </p:txBody>
+      </p:sp>
       <p:pic>
         <p:nvPicPr>
           <p:cNvPr id="3" name="Picture 2">
@@ -8972,140 +9106,6 @@
           </a:prstGeom>
         </p:spPr>
       </p:pic>
-      <p:sp>
-        <p:nvSpPr>
-          <p:cNvPr id="100" name="BgRect"/>
-          <p:cNvSpPr/>
-          <p:nvPr/>
-        </p:nvSpPr>
-        <p:spPr>
-          <a:xfrm>
-            <a:off x="0" y="0"/>
-            <a:ext cx="9144000" cy="5143500"/>
-          </a:xfrm>
-          <a:prstGeom prst="rect">
-            <a:avLst/>
-          </a:prstGeom>
-          <a:solidFill>
-            <a:srgbClr val="0B1A33"/>
-          </a:solidFill>
-          <a:ln>
-            <a:noFill/>
-          </a:ln>
-        </p:spPr>
-        <p:txBody>
-          <a:bodyPr/>
-          <a:lstStyle/>
-          <a:p>
-            <a:endParaRPr lang="en-US"/>
-          </a:p>
-        </p:txBody>
-      </p:sp>
-      <p:sp>
-        <p:nvSpPr>
-          <p:cNvPr id="101" name="AccentBar"/>
-          <p:cNvSpPr/>
-          <p:nvPr/>
-        </p:nvSpPr>
-        <p:spPr>
-          <a:xfrm>
-            <a:off x="0" y="0"/>
-            <a:ext cx="9144000" cy="54864"/>
-          </a:xfrm>
-          <a:prstGeom prst="rect">
-            <a:avLst/>
-          </a:prstGeom>
-          <a:solidFill>
-            <a:srgbClr val="2563EB"/>
-          </a:solidFill>
-          <a:ln>
-            <a:noFill/>
-          </a:ln>
-        </p:spPr>
-        <p:txBody>
-          <a:bodyPr/>
-          <a:lstStyle/>
-          <a:p>
-            <a:endParaRPr lang="en-US"/>
-          </a:p>
-        </p:txBody>
-      </p:sp>
-      <p:sp>
-        <p:nvSpPr>
-          <p:cNvPr id="102" name="Title"/>
-          <p:cNvSpPr/>
-          <p:nvPr/>
-        </p:nvSpPr>
-        <p:spPr>
-          <a:xfrm>
-            <a:off x="457200" y="137160"/>
-            <a:ext cx="8229600" cy="365760"/>
-          </a:xfrm>
-          <a:prstGeom prst="rect">
-            <a:avLst/>
-          </a:prstGeom>
-          <a:noFill/>
-          <a:ln>
-            <a:noFill/>
-          </a:ln>
-        </p:spPr>
-        <p:txBody>
-          <a:bodyPr wrap="square" lIns="0" tIns="0" rIns="0" bIns="0" rtlCol="0" anchor="b"/>
-          <a:lstStyle/>
-          <a:p>
-            <a:pPr marL="0" indent="0">
-              <a:buNone/>
-            </a:pPr>
-            <a:r>
-              <a:rPr lang="en-US" sz="2000" b="1" dirty="0">
-                <a:solidFill>
-                  <a:srgbClr val="FFFFFF"/>
-                </a:solidFill>
-                <a:latin typeface="Calibri" pitchFamily="34" charset="0"/>
-              </a:rPr>
-              <a:t>Step 2: Upload  &amp; Configure</a:t>
-            </a:r>
-          </a:p>
-        </p:txBody>
-      </p:sp>
-      <p:sp>
-        <p:nvSpPr>
-          <p:cNvPr id="103" name="Subtitle"/>
-          <p:cNvSpPr/>
-          <p:nvPr/>
-        </p:nvSpPr>
-        <p:spPr>
-          <a:xfrm>
-            <a:off x="457200" y="502920"/>
-            <a:ext cx="8229600" cy="274320"/>
-          </a:xfrm>
-          <a:prstGeom prst="rect">
-            <a:avLst/>
-          </a:prstGeom>
-          <a:noFill/>
-          <a:ln>
-            <a:noFill/>
-          </a:ln>
-        </p:spPr>
-        <p:txBody>
-          <a:bodyPr wrap="square" lIns="0" tIns="0" rIns="0" bIns="0" rtlCol="0" anchor="t"/>
-          <a:lstStyle/>
-          <a:p>
-            <a:pPr marL="0" indent="0">
-              <a:buNone/>
-            </a:pPr>
-            <a:r>
-              <a:rPr lang="en-US" sz="1100" dirty="0">
-                <a:solidFill>
-                  <a:srgbClr val="93C5FD"/>
-                </a:solidFill>
-                <a:latin typeface="Calibri" pitchFamily="34" charset="0"/>
-              </a:rPr>
-              <a:t>Drag  &amp; drop MuleSoft project, set migration options, enable AI enhancement</a:t>
-            </a:r>
-          </a:p>
-        </p:txBody>
-      </p:sp>
     </p:spTree>
     <p:extLst>
       <p:ext uri="{BB962C8B-B14F-4D97-AF65-F5344CB8AC3E}">
@@ -9136,6 +9136,140 @@
           <a:chExt cx="0" cy="0"/>
         </a:xfrm>
       </p:grpSpPr>
+      <p:sp>
+        <p:nvSpPr>
+          <p:cNvPr id="100" name="HeaderStrip"/>
+          <p:cNvSpPr/>
+          <p:nvPr/>
+        </p:nvSpPr>
+        <p:spPr>
+          <a:xfrm>
+            <a:off x="0" y="0"/>
+            <a:ext cx="9144000" cy="822960"/>
+          </a:xfrm>
+          <a:prstGeom prst="rect">
+            <a:avLst/>
+          </a:prstGeom>
+          <a:solidFill>
+            <a:srgbClr val="0B1A33"/>
+          </a:solidFill>
+          <a:ln>
+            <a:noFill/>
+          </a:ln>
+        </p:spPr>
+        <p:txBody>
+          <a:bodyPr/>
+          <a:lstStyle/>
+          <a:p>
+            <a:endParaRPr lang="en-US"/>
+          </a:p>
+        </p:txBody>
+      </p:sp>
+      <p:sp>
+        <p:nvSpPr>
+          <p:cNvPr id="101" name="AccentBar"/>
+          <p:cNvSpPr/>
+          <p:nvPr/>
+        </p:nvSpPr>
+        <p:spPr>
+          <a:xfrm>
+            <a:off x="0" y="0"/>
+            <a:ext cx="9144000" cy="54864"/>
+          </a:xfrm>
+          <a:prstGeom prst="rect">
+            <a:avLst/>
+          </a:prstGeom>
+          <a:solidFill>
+            <a:srgbClr val="2563EB"/>
+          </a:solidFill>
+          <a:ln>
+            <a:noFill/>
+          </a:ln>
+        </p:spPr>
+        <p:txBody>
+          <a:bodyPr/>
+          <a:lstStyle/>
+          <a:p>
+            <a:endParaRPr lang="en-US"/>
+          </a:p>
+        </p:txBody>
+      </p:sp>
+      <p:sp>
+        <p:nvSpPr>
+          <p:cNvPr id="102" name="Title"/>
+          <p:cNvSpPr/>
+          <p:nvPr/>
+        </p:nvSpPr>
+        <p:spPr>
+          <a:xfrm>
+            <a:off x="457200" y="137160"/>
+            <a:ext cx="8229600" cy="365760"/>
+          </a:xfrm>
+          <a:prstGeom prst="rect">
+            <a:avLst/>
+          </a:prstGeom>
+          <a:noFill/>
+          <a:ln>
+            <a:noFill/>
+          </a:ln>
+        </p:spPr>
+        <p:txBody>
+          <a:bodyPr wrap="square" lIns="0" tIns="0" rIns="0" bIns="0" rtlCol="0" anchor="b"/>
+          <a:lstStyle/>
+          <a:p>
+            <a:pPr marL="0" indent="0">
+              <a:buNone/>
+            </a:pPr>
+            <a:r>
+              <a:rPr lang="en-US" sz="2000" b="1" dirty="0">
+                <a:solidFill>
+                  <a:srgbClr val="FFFFFF"/>
+                </a:solidFill>
+                <a:latin typeface="Calibri" pitchFamily="34" charset="0"/>
+              </a:rPr>
+              <a:t>Step 3: Migration Complete</a:t>
+            </a:r>
+          </a:p>
+        </p:txBody>
+      </p:sp>
+      <p:sp>
+        <p:nvSpPr>
+          <p:cNvPr id="103" name="Subtitle"/>
+          <p:cNvSpPr/>
+          <p:nvPr/>
+        </p:nvSpPr>
+        <p:spPr>
+          <a:xfrm>
+            <a:off x="457200" y="502920"/>
+            <a:ext cx="8229600" cy="274320"/>
+          </a:xfrm>
+          <a:prstGeom prst="rect">
+            <a:avLst/>
+          </a:prstGeom>
+          <a:noFill/>
+          <a:ln>
+            <a:noFill/>
+          </a:ln>
+        </p:spPr>
+        <p:txBody>
+          <a:bodyPr wrap="square" lIns="0" tIns="0" rIns="0" bIns="0" rtlCol="0" anchor="t"/>
+          <a:lstStyle/>
+          <a:p>
+            <a:pPr marL="0" indent="0">
+              <a:buNone/>
+            </a:pPr>
+            <a:r>
+              <a:rPr lang="en-US" sz="1100" dirty="0">
+                <a:solidFill>
+                  <a:srgbClr val="93C5FD"/>
+                </a:solidFill>
+                <a:latin typeface="Calibri" pitchFamily="34" charset="0"/>
+              </a:rPr>
+              <a:t>Generated files, agent pipeline status, cost summary  &amp; actions</a:t>
+            </a:r>
+          </a:p>
+        </p:txBody>
+      </p:sp>
       <p:pic>
         <p:nvPicPr>
           <p:cNvPr id="3" name="Picture 2">
@@ -9166,140 +9300,6 @@
           </a:prstGeom>
         </p:spPr>
       </p:pic>
-      <p:sp>
-        <p:nvSpPr>
-          <p:cNvPr id="100" name="BgRect"/>
-          <p:cNvSpPr/>
-          <p:nvPr/>
-        </p:nvSpPr>
-        <p:spPr>
-          <a:xfrm>
-            <a:off x="0" y="0"/>
-            <a:ext cx="9144000" cy="5143500"/>
-          </a:xfrm>
-          <a:prstGeom prst="rect">
-            <a:avLst/>
-          </a:prstGeom>
-          <a:solidFill>
-            <a:srgbClr val="0B1A33"/>
-          </a:solidFill>
-          <a:ln>
-            <a:noFill/>
-          </a:ln>
-        </p:spPr>
-        <p:txBody>
-          <a:bodyPr/>
-          <a:lstStyle/>
-          <a:p>
-            <a:endParaRPr lang="en-US"/>
-          </a:p>
-        </p:txBody>
-      </p:sp>
-      <p:sp>
-        <p:nvSpPr>
-          <p:cNvPr id="101" name="AccentBar"/>
-          <p:cNvSpPr/>
-          <p:nvPr/>
-        </p:nvSpPr>
-        <p:spPr>
-          <a:xfrm>
-            <a:off x="0" y="0"/>
-            <a:ext cx="9144000" cy="54864"/>
-          </a:xfrm>
-          <a:prstGeom prst="rect">
-            <a:avLst/>
-          </a:prstGeom>
-          <a:solidFill>
-            <a:srgbClr val="2563EB"/>
-          </a:solidFill>
-          <a:ln>
-            <a:noFill/>
-          </a:ln>
-        </p:spPr>
-        <p:txBody>
-          <a:bodyPr/>
-          <a:lstStyle/>
-          <a:p>
-            <a:endParaRPr lang="en-US"/>
-          </a:p>
-        </p:txBody>
-      </p:sp>
-      <p:sp>
-        <p:nvSpPr>
-          <p:cNvPr id="102" name="Title"/>
-          <p:cNvSpPr/>
-          <p:nvPr/>
-        </p:nvSpPr>
-        <p:spPr>
-          <a:xfrm>
-            <a:off x="457200" y="137160"/>
-            <a:ext cx="8229600" cy="365760"/>
-          </a:xfrm>
-          <a:prstGeom prst="rect">
-            <a:avLst/>
-          </a:prstGeom>
-          <a:noFill/>
-          <a:ln>
-            <a:noFill/>
-          </a:ln>
-        </p:spPr>
-        <p:txBody>
-          <a:bodyPr wrap="square" lIns="0" tIns="0" rIns="0" bIns="0" rtlCol="0" anchor="b"/>
-          <a:lstStyle/>
-          <a:p>
-            <a:pPr marL="0" indent="0">
-              <a:buNone/>
-            </a:pPr>
-            <a:r>
-              <a:rPr lang="en-US" sz="2000" b="1" dirty="0">
-                <a:solidFill>
-                  <a:srgbClr val="FFFFFF"/>
-                </a:solidFill>
-                <a:latin typeface="Calibri" pitchFamily="34" charset="0"/>
-              </a:rPr>
-              <a:t>Step 3: Migration Complete</a:t>
-            </a:r>
-          </a:p>
-        </p:txBody>
-      </p:sp>
-      <p:sp>
-        <p:nvSpPr>
-          <p:cNvPr id="103" name="Subtitle"/>
-          <p:cNvSpPr/>
-          <p:nvPr/>
-        </p:nvSpPr>
-        <p:spPr>
-          <a:xfrm>
-            <a:off x="457200" y="502920"/>
-            <a:ext cx="8229600" cy="274320"/>
-          </a:xfrm>
-          <a:prstGeom prst="rect">
-            <a:avLst/>
-          </a:prstGeom>
-          <a:noFill/>
-          <a:ln>
-            <a:noFill/>
-          </a:ln>
-        </p:spPr>
-        <p:txBody>
-          <a:bodyPr wrap="square" lIns="0" tIns="0" rIns="0" bIns="0" rtlCol="0" anchor="t"/>
-          <a:lstStyle/>
-          <a:p>
-            <a:pPr marL="0" indent="0">
-              <a:buNone/>
-            </a:pPr>
-            <a:r>
-              <a:rPr lang="en-US" sz="1100" dirty="0">
-                <a:solidFill>
-                  <a:srgbClr val="93C5FD"/>
-                </a:solidFill>
-                <a:latin typeface="Calibri" pitchFamily="34" charset="0"/>
-              </a:rPr>
-              <a:t>Generated files, agent pipeline status, cost summary  &amp; actions</a:t>
-            </a:r>
-          </a:p>
-        </p:txBody>
-      </p:sp>
     </p:spTree>
     <p:extLst>
       <p:ext uri="{BB962C8B-B14F-4D97-AF65-F5344CB8AC3E}">
@@ -9330,6 +9330,140 @@
           <a:chExt cx="0" cy="0"/>
         </a:xfrm>
       </p:grpSpPr>
+      <p:sp>
+        <p:nvSpPr>
+          <p:cNvPr id="100" name="HeaderStrip"/>
+          <p:cNvSpPr/>
+          <p:nvPr/>
+        </p:nvSpPr>
+        <p:spPr>
+          <a:xfrm>
+            <a:off x="0" y="0"/>
+            <a:ext cx="9144000" cy="822960"/>
+          </a:xfrm>
+          <a:prstGeom prst="rect">
+            <a:avLst/>
+          </a:prstGeom>
+          <a:solidFill>
+            <a:srgbClr val="0B1A33"/>
+          </a:solidFill>
+          <a:ln>
+            <a:noFill/>
+          </a:ln>
+        </p:spPr>
+        <p:txBody>
+          <a:bodyPr/>
+          <a:lstStyle/>
+          <a:p>
+            <a:endParaRPr lang="en-US"/>
+          </a:p>
+        </p:txBody>
+      </p:sp>
+      <p:sp>
+        <p:nvSpPr>
+          <p:cNvPr id="101" name="AccentBar"/>
+          <p:cNvSpPr/>
+          <p:nvPr/>
+        </p:nvSpPr>
+        <p:spPr>
+          <a:xfrm>
+            <a:off x="0" y="0"/>
+            <a:ext cx="9144000" cy="54864"/>
+          </a:xfrm>
+          <a:prstGeom prst="rect">
+            <a:avLst/>
+          </a:prstGeom>
+          <a:solidFill>
+            <a:srgbClr val="2563EB"/>
+          </a:solidFill>
+          <a:ln>
+            <a:noFill/>
+          </a:ln>
+        </p:spPr>
+        <p:txBody>
+          <a:bodyPr/>
+          <a:lstStyle/>
+          <a:p>
+            <a:endParaRPr lang="en-US"/>
+          </a:p>
+        </p:txBody>
+      </p:sp>
+      <p:sp>
+        <p:nvSpPr>
+          <p:cNvPr id="102" name="Title"/>
+          <p:cNvSpPr/>
+          <p:nvPr/>
+        </p:nvSpPr>
+        <p:spPr>
+          <a:xfrm>
+            <a:off x="457200" y="137160"/>
+            <a:ext cx="8229600" cy="365760"/>
+          </a:xfrm>
+          <a:prstGeom prst="rect">
+            <a:avLst/>
+          </a:prstGeom>
+          <a:noFill/>
+          <a:ln>
+            <a:noFill/>
+          </a:ln>
+        </p:spPr>
+        <p:txBody>
+          <a:bodyPr wrap="square" lIns="0" tIns="0" rIns="0" bIns="0" rtlCol="0" anchor="b"/>
+          <a:lstStyle/>
+          <a:p>
+            <a:pPr marL="0" indent="0">
+              <a:buNone/>
+            </a:pPr>
+            <a:r>
+              <a:rPr lang="en-US" sz="2000" b="1" dirty="0">
+                <a:solidFill>
+                  <a:srgbClr val="FFFFFF"/>
+                </a:solidFill>
+                <a:latin typeface="Calibri" pitchFamily="34" charset="0"/>
+              </a:rPr>
+              <a:t>Step 4: Swagger Preview</a:t>
+            </a:r>
+          </a:p>
+        </p:txBody>
+      </p:sp>
+      <p:sp>
+        <p:nvSpPr>
+          <p:cNvPr id="103" name="Subtitle"/>
+          <p:cNvSpPr/>
+          <p:nvPr/>
+        </p:nvSpPr>
+        <p:spPr>
+          <a:xfrm>
+            <a:off x="457200" y="502920"/>
+            <a:ext cx="8229600" cy="274320"/>
+          </a:xfrm>
+          <a:prstGeom prst="rect">
+            <a:avLst/>
+          </a:prstGeom>
+          <a:noFill/>
+          <a:ln>
+            <a:noFill/>
+          </a:ln>
+        </p:spPr>
+        <p:txBody>
+          <a:bodyPr wrap="square" lIns="0" tIns="0" rIns="0" bIns="0" rtlCol="0" anchor="t"/>
+          <a:lstStyle/>
+          <a:p>
+            <a:pPr marL="0" indent="0">
+              <a:buNone/>
+            </a:pPr>
+            <a:r>
+              <a:rPr lang="en-US" sz="1100" dirty="0">
+                <a:solidFill>
+                  <a:srgbClr val="93C5FD"/>
+                </a:solidFill>
+                <a:latin typeface="Calibri" pitchFamily="34" charset="0"/>
+              </a:rPr>
+              <a:t>Auto-generated OpenAPI 3.0 spec with all endpoints documented</a:t>
+            </a:r>
+          </a:p>
+        </p:txBody>
+      </p:sp>
       <p:pic>
         <p:nvPicPr>
           <p:cNvPr id="3" name="Picture 2">
@@ -9360,140 +9494,6 @@
           </a:prstGeom>
         </p:spPr>
       </p:pic>
-      <p:sp>
-        <p:nvSpPr>
-          <p:cNvPr id="100" name="BgRect"/>
-          <p:cNvSpPr/>
-          <p:nvPr/>
-        </p:nvSpPr>
-        <p:spPr>
-          <a:xfrm>
-            <a:off x="0" y="0"/>
-            <a:ext cx="9144000" cy="5143500"/>
-          </a:xfrm>
-          <a:prstGeom prst="rect">
-            <a:avLst/>
-          </a:prstGeom>
-          <a:solidFill>
-            <a:srgbClr val="0B1A33"/>
-          </a:solidFill>
-          <a:ln>
-            <a:noFill/>
-          </a:ln>
-        </p:spPr>
-        <p:txBody>
-          <a:bodyPr/>
-          <a:lstStyle/>
-          <a:p>
-            <a:endParaRPr lang="en-US"/>
-          </a:p>
-        </p:txBody>
-      </p:sp>
-      <p:sp>
-        <p:nvSpPr>
-          <p:cNvPr id="101" name="AccentBar"/>
-          <p:cNvSpPr/>
-          <p:nvPr/>
-        </p:nvSpPr>
-        <p:spPr>
-          <a:xfrm>
-            <a:off x="0" y="0"/>
-            <a:ext cx="9144000" cy="54864"/>
-          </a:xfrm>
-          <a:prstGeom prst="rect">
-            <a:avLst/>
-          </a:prstGeom>
-          <a:solidFill>
-            <a:srgbClr val="2563EB"/>
-          </a:solidFill>
-          <a:ln>
-            <a:noFill/>
-          </a:ln>
-        </p:spPr>
-        <p:txBody>
-          <a:bodyPr/>
-          <a:lstStyle/>
-          <a:p>
-            <a:endParaRPr lang="en-US"/>
-          </a:p>
-        </p:txBody>
-      </p:sp>
-      <p:sp>
-        <p:nvSpPr>
-          <p:cNvPr id="102" name="Title"/>
-          <p:cNvSpPr/>
-          <p:nvPr/>
-        </p:nvSpPr>
-        <p:spPr>
-          <a:xfrm>
-            <a:off x="457200" y="137160"/>
-            <a:ext cx="8229600" cy="365760"/>
-          </a:xfrm>
-          <a:prstGeom prst="rect">
-            <a:avLst/>
-          </a:prstGeom>
-          <a:noFill/>
-          <a:ln>
-            <a:noFill/>
-          </a:ln>
-        </p:spPr>
-        <p:txBody>
-          <a:bodyPr wrap="square" lIns="0" tIns="0" rIns="0" bIns="0" rtlCol="0" anchor="b"/>
-          <a:lstStyle/>
-          <a:p>
-            <a:pPr marL="0" indent="0">
-              <a:buNone/>
-            </a:pPr>
-            <a:r>
-              <a:rPr lang="en-US" sz="2000" b="1" dirty="0">
-                <a:solidFill>
-                  <a:srgbClr val="FFFFFF"/>
-                </a:solidFill>
-                <a:latin typeface="Calibri" pitchFamily="34" charset="0"/>
-              </a:rPr>
-              <a:t>Step 4: Swagger Preview</a:t>
-            </a:r>
-          </a:p>
-        </p:txBody>
-      </p:sp>
-      <p:sp>
-        <p:nvSpPr>
-          <p:cNvPr id="103" name="Subtitle"/>
-          <p:cNvSpPr/>
-          <p:nvPr/>
-        </p:nvSpPr>
-        <p:spPr>
-          <a:xfrm>
-            <a:off x="457200" y="502920"/>
-            <a:ext cx="8229600" cy="274320"/>
-          </a:xfrm>
-          <a:prstGeom prst="rect">
-            <a:avLst/>
-          </a:prstGeom>
-          <a:noFill/>
-          <a:ln>
-            <a:noFill/>
-          </a:ln>
-        </p:spPr>
-        <p:txBody>
-          <a:bodyPr wrap="square" lIns="0" tIns="0" rIns="0" bIns="0" rtlCol="0" anchor="t"/>
-          <a:lstStyle/>
-          <a:p>
-            <a:pPr marL="0" indent="0">
-              <a:buNone/>
-            </a:pPr>
-            <a:r>
-              <a:rPr lang="en-US" sz="1100" dirty="0">
-                <a:solidFill>
-                  <a:srgbClr val="93C5FD"/>
-                </a:solidFill>
-                <a:latin typeface="Calibri" pitchFamily="34" charset="0"/>
-              </a:rPr>
-              <a:t>Auto-generated OpenAPI 3.0 spec with all endpoints documented</a:t>
-            </a:r>
-          </a:p>
-        </p:txBody>
-      </p:sp>
     </p:spTree>
     <p:extLst>
       <p:ext uri="{BB962C8B-B14F-4D97-AF65-F5344CB8AC3E}">
@@ -9524,6 +9524,140 @@
           <a:chExt cx="0" cy="0"/>
         </a:xfrm>
       </p:grpSpPr>
+      <p:sp>
+        <p:nvSpPr>
+          <p:cNvPr id="100" name="HeaderStrip"/>
+          <p:cNvSpPr/>
+          <p:nvPr/>
+        </p:nvSpPr>
+        <p:spPr>
+          <a:xfrm>
+            <a:off x="0" y="0"/>
+            <a:ext cx="9144000" cy="822960"/>
+          </a:xfrm>
+          <a:prstGeom prst="rect">
+            <a:avLst/>
+          </a:prstGeom>
+          <a:solidFill>
+            <a:srgbClr val="0B1A33"/>
+          </a:solidFill>
+          <a:ln>
+            <a:noFill/>
+          </a:ln>
+        </p:spPr>
+        <p:txBody>
+          <a:bodyPr/>
+          <a:lstStyle/>
+          <a:p>
+            <a:endParaRPr lang="en-US"/>
+          </a:p>
+        </p:txBody>
+      </p:sp>
+      <p:sp>
+        <p:nvSpPr>
+          <p:cNvPr id="101" name="AccentBar"/>
+          <p:cNvSpPr/>
+          <p:nvPr/>
+        </p:nvSpPr>
+        <p:spPr>
+          <a:xfrm>
+            <a:off x="0" y="0"/>
+            <a:ext cx="9144000" cy="54864"/>
+          </a:xfrm>
+          <a:prstGeom prst="rect">
+            <a:avLst/>
+          </a:prstGeom>
+          <a:solidFill>
+            <a:srgbClr val="2563EB"/>
+          </a:solidFill>
+          <a:ln>
+            <a:noFill/>
+          </a:ln>
+        </p:spPr>
+        <p:txBody>
+          <a:bodyPr/>
+          <a:lstStyle/>
+          <a:p>
+            <a:endParaRPr lang="en-US"/>
+          </a:p>
+        </p:txBody>
+      </p:sp>
+      <p:sp>
+        <p:nvSpPr>
+          <p:cNvPr id="102" name="Title"/>
+          <p:cNvSpPr/>
+          <p:nvPr/>
+        </p:nvSpPr>
+        <p:spPr>
+          <a:xfrm>
+            <a:off x="457200" y="137160"/>
+            <a:ext cx="8229600" cy="365760"/>
+          </a:xfrm>
+          <a:prstGeom prst="rect">
+            <a:avLst/>
+          </a:prstGeom>
+          <a:noFill/>
+          <a:ln>
+            <a:noFill/>
+          </a:ln>
+        </p:spPr>
+        <p:txBody>
+          <a:bodyPr wrap="square" lIns="0" tIns="0" rIns="0" bIns="0" rtlCol="0" anchor="b"/>
+          <a:lstStyle/>
+          <a:p>
+            <a:pPr marL="0" indent="0">
+              <a:buNone/>
+            </a:pPr>
+            <a:r>
+              <a:rPr lang="en-US" sz="2000" b="1" dirty="0">
+                <a:solidFill>
+                  <a:srgbClr val="FFFFFF"/>
+                </a:solidFill>
+                <a:latin typeface="Calibri" pitchFamily="34" charset="0"/>
+              </a:rPr>
+              <a:t>Step 5: Push to GitHub</a:t>
+            </a:r>
+          </a:p>
+        </p:txBody>
+      </p:sp>
+      <p:sp>
+        <p:nvSpPr>
+          <p:cNvPr id="103" name="Subtitle"/>
+          <p:cNvSpPr/>
+          <p:nvPr/>
+        </p:nvSpPr>
+        <p:spPr>
+          <a:xfrm>
+            <a:off x="457200" y="502920"/>
+            <a:ext cx="8229600" cy="274320"/>
+          </a:xfrm>
+          <a:prstGeom prst="rect">
+            <a:avLst/>
+          </a:prstGeom>
+          <a:noFill/>
+          <a:ln>
+            <a:noFill/>
+          </a:ln>
+        </p:spPr>
+        <p:txBody>
+          <a:bodyPr wrap="square" lIns="0" tIns="0" rIns="0" bIns="0" rtlCol="0" anchor="t"/>
+          <a:lstStyle/>
+          <a:p>
+            <a:pPr marL="0" indent="0">
+              <a:buNone/>
+            </a:pPr>
+            <a:r>
+              <a:rPr lang="en-US" sz="1100" dirty="0">
+                <a:solidFill>
+                  <a:srgbClr val="93C5FD"/>
+                </a:solidFill>
+                <a:latin typeface="Calibri" pitchFamily="34" charset="0"/>
+              </a:rPr>
+              <a:t>Connect GitHub token, configure repo, branch  &amp; push generated code</a:t>
+            </a:r>
+          </a:p>
+        </p:txBody>
+      </p:sp>
       <p:pic>
         <p:nvPicPr>
           <p:cNvPr id="3" name="Picture 2">
@@ -9554,140 +9688,6 @@
           </a:prstGeom>
         </p:spPr>
       </p:pic>
-      <p:sp>
-        <p:nvSpPr>
-          <p:cNvPr id="100" name="BgRect"/>
-          <p:cNvSpPr/>
-          <p:nvPr/>
-        </p:nvSpPr>
-        <p:spPr>
-          <a:xfrm>
-            <a:off x="0" y="0"/>
-            <a:ext cx="9144000" cy="5143500"/>
-          </a:xfrm>
-          <a:prstGeom prst="rect">
-            <a:avLst/>
-          </a:prstGeom>
-          <a:solidFill>
-            <a:srgbClr val="0B1A33"/>
-          </a:solidFill>
-          <a:ln>
-            <a:noFill/>
-          </a:ln>
-        </p:spPr>
-        <p:txBody>
-          <a:bodyPr/>
-          <a:lstStyle/>
-          <a:p>
-            <a:endParaRPr lang="en-US"/>
-          </a:p>
-        </p:txBody>
-      </p:sp>
-      <p:sp>
-        <p:nvSpPr>
-          <p:cNvPr id="101" name="AccentBar"/>
-          <p:cNvSpPr/>
-          <p:nvPr/>
-        </p:nvSpPr>
-        <p:spPr>
-          <a:xfrm>
-            <a:off x="0" y="0"/>
-            <a:ext cx="9144000" cy="54864"/>
-          </a:xfrm>
-          <a:prstGeom prst="rect">
-            <a:avLst/>
-          </a:prstGeom>
-          <a:solidFill>
-            <a:srgbClr val="2563EB"/>
-          </a:solidFill>
-          <a:ln>
-            <a:noFill/>
-          </a:ln>
-        </p:spPr>
-        <p:txBody>
-          <a:bodyPr/>
-          <a:lstStyle/>
-          <a:p>
-            <a:endParaRPr lang="en-US"/>
-          </a:p>
-        </p:txBody>
-      </p:sp>
-      <p:sp>
-        <p:nvSpPr>
-          <p:cNvPr id="102" name="Title"/>
-          <p:cNvSpPr/>
-          <p:nvPr/>
-        </p:nvSpPr>
-        <p:spPr>
-          <a:xfrm>
-            <a:off x="457200" y="137160"/>
-            <a:ext cx="8229600" cy="365760"/>
-          </a:xfrm>
-          <a:prstGeom prst="rect">
-            <a:avLst/>
-          </a:prstGeom>
-          <a:noFill/>
-          <a:ln>
-            <a:noFill/>
-          </a:ln>
-        </p:spPr>
-        <p:txBody>
-          <a:bodyPr wrap="square" lIns="0" tIns="0" rIns="0" bIns="0" rtlCol="0" anchor="b"/>
-          <a:lstStyle/>
-          <a:p>
-            <a:pPr marL="0" indent="0">
-              <a:buNone/>
-            </a:pPr>
-            <a:r>
-              <a:rPr lang="en-US" sz="2000" b="1" dirty="0">
-                <a:solidFill>
-                  <a:srgbClr val="FFFFFF"/>
-                </a:solidFill>
-                <a:latin typeface="Calibri" pitchFamily="34" charset="0"/>
-              </a:rPr>
-              <a:t>Step 5: Push to GitHub</a:t>
-            </a:r>
-          </a:p>
-        </p:txBody>
-      </p:sp>
-      <p:sp>
-        <p:nvSpPr>
-          <p:cNvPr id="103" name="Subtitle"/>
-          <p:cNvSpPr/>
-          <p:nvPr/>
-        </p:nvSpPr>
-        <p:spPr>
-          <a:xfrm>
-            <a:off x="457200" y="502920"/>
-            <a:ext cx="8229600" cy="274320"/>
-          </a:xfrm>
-          <a:prstGeom prst="rect">
-            <a:avLst/>
-          </a:prstGeom>
-          <a:noFill/>
-          <a:ln>
-            <a:noFill/>
-          </a:ln>
-        </p:spPr>
-        <p:txBody>
-          <a:bodyPr wrap="square" lIns="0" tIns="0" rIns="0" bIns="0" rtlCol="0" anchor="t"/>
-          <a:lstStyle/>
-          <a:p>
-            <a:pPr marL="0" indent="0">
-              <a:buNone/>
-            </a:pPr>
-            <a:r>
-              <a:rPr lang="en-US" sz="1100" dirty="0">
-                <a:solidFill>
-                  <a:srgbClr val="93C5FD"/>
-                </a:solidFill>
-                <a:latin typeface="Calibri" pitchFamily="34" charset="0"/>
-              </a:rPr>
-              <a:t>Connect GitHub token, configure repo, branch  &amp; push generated code</a:t>
-            </a:r>
-          </a:p>
-        </p:txBody>
-      </p:sp>
     </p:spTree>
     <p:extLst>
       <p:ext uri="{BB962C8B-B14F-4D97-AF65-F5344CB8AC3E}">

</xml_diff>